<commit_message>
Show cleaning counterfactual in final pitch
</commit_message>
<xml_diff>
--- a/output/presentations/hawkerbridge-final-pitch.pptx
+++ b/output/presentations/hawkerbridge-final-pitch.pptx
@@ -2,21 +2,21 @@
 <file path=ppt/presentation.xml><?xml version="1.0" encoding="utf-8"?>
 <p:presentation xmlns:p="http://schemas.openxmlformats.org/presentationml/2006/main">
   <p:sldMasterIdLst>
-    <p:sldMasterId xmlns:r="http://schemas.openxmlformats.org/officeDocument/2006/relationships" id="2147483648" r:id="Ra606295355d34c9c"/>
+    <p:sldMasterId xmlns:r="http://schemas.openxmlformats.org/officeDocument/2006/relationships" id="2147483648" r:id="R3444339f307942ad"/>
   </p:sldMasterIdLst>
   <p:notesMasterIdLst>
-    <p:notesMasterId xmlns:r="http://schemas.openxmlformats.org/officeDocument/2006/relationships" r:id="R6a63f0be913b455c"/>
+    <p:notesMasterId xmlns:r="http://schemas.openxmlformats.org/officeDocument/2006/relationships" r:id="Rc76b4fb64d994445"/>
   </p:notesMasterIdLst>
   <p:sldIdLst>
-    <p:sldId xmlns:r="http://schemas.openxmlformats.org/officeDocument/2006/relationships" id="256" r:id="R1dc7b5b72b62434f"/>
-    <p:sldId xmlns:r="http://schemas.openxmlformats.org/officeDocument/2006/relationships" id="257" r:id="R2f492ffe7dd743ac"/>
-    <p:sldId xmlns:r="http://schemas.openxmlformats.org/officeDocument/2006/relationships" id="258" r:id="R8800a87dc0b74ec2"/>
-    <p:sldId xmlns:r="http://schemas.openxmlformats.org/officeDocument/2006/relationships" id="259" r:id="Rd4e61251dbe34d08"/>
-    <p:sldId xmlns:r="http://schemas.openxmlformats.org/officeDocument/2006/relationships" id="260" r:id="R84a88d6cd26b4214"/>
-    <p:sldId xmlns:r="http://schemas.openxmlformats.org/officeDocument/2006/relationships" id="261" r:id="Rbe244347545249ed"/>
-    <p:sldId xmlns:r="http://schemas.openxmlformats.org/officeDocument/2006/relationships" id="262" r:id="R2be2b6f52bf6422b"/>
-    <p:sldId xmlns:r="http://schemas.openxmlformats.org/officeDocument/2006/relationships" id="263" r:id="R192e3e277fca476b"/>
-    <p:sldId xmlns:r="http://schemas.openxmlformats.org/officeDocument/2006/relationships" id="264" r:id="Rb90f99361ab94cac"/>
+    <p:sldId xmlns:r="http://schemas.openxmlformats.org/officeDocument/2006/relationships" id="256" r:id="R291de8099a5e419a"/>
+    <p:sldId xmlns:r="http://schemas.openxmlformats.org/officeDocument/2006/relationships" id="257" r:id="R87302f453ca8404d"/>
+    <p:sldId xmlns:r="http://schemas.openxmlformats.org/officeDocument/2006/relationships" id="258" r:id="Re3d59d71ec5a4af6"/>
+    <p:sldId xmlns:r="http://schemas.openxmlformats.org/officeDocument/2006/relationships" id="259" r:id="R23863fc36ec6401c"/>
+    <p:sldId xmlns:r="http://schemas.openxmlformats.org/officeDocument/2006/relationships" id="260" r:id="R0bdbd60fc2164212"/>
+    <p:sldId xmlns:r="http://schemas.openxmlformats.org/officeDocument/2006/relationships" id="261" r:id="Rdaa9dd89bbaf4b62"/>
+    <p:sldId xmlns:r="http://schemas.openxmlformats.org/officeDocument/2006/relationships" id="262" r:id="R3d2829ccf4614acd"/>
+    <p:sldId xmlns:r="http://schemas.openxmlformats.org/officeDocument/2006/relationships" id="263" r:id="R3ef7cddf3507447b"/>
+    <p:sldId xmlns:r="http://schemas.openxmlformats.org/officeDocument/2006/relationships" id="264" r:id="Rc41e24307da14fe2"/>
   </p:sldIdLst>
   <p:sldSz cx="12192000" cy="6858000"/>
   <p:notesSz cx="6858000" cy="9144000"/>
@@ -590,7 +590,7 @@
           <a:lstStyle xmlns:a="http://schemas.openxmlformats.org/drawingml/2006/main"/>
           <a:p xmlns:a="http://schemas.openxmlformats.org/drawingml/2006/main">
             <a:r>
-              <a:t>Screenshot provenance is recorded in scripts/presentations/assets/README.md. Product code: frontend/src/App.tsx and backend/hawkerbridge/engine.py. This is the working application, not a design mockup. For the dated 28 Sep 2026 model at 800 m, six populated subzones contain 91,180 census residents and 17,120 seniors whose representative points lose listed hawker coverage. These are not observed hungry residents. Dates of Hawker Centres Closure: https://data.gov.sg/datasets/d_bda4baa634dd1cc7a6c7cad5f19e2d68/view</a:t>
+              <a:t>Screenshot provenance is recorded in scripts/presentations/assets/README.md. Product code: frontend/src/App.tsx and backend/hawkerbridge/engine.py. This is the working application, not a design mockup. The cleaning counterfactual removes a chosen adjustable event from the selected day for comparison. It does not modify a published government closure schedule or choose an operationally valid replacement date. For the dated 28 Sep 2026 model at 800 m, six populated subzones contain 91,180 census residents and 17,120 seniors whose representative points lose listed hawker coverage. These are not observed hungry residents. The screen omits coffee shops, food courts, individual needs and accessible walking routes. Dates of Hawker Centres Closure: https://data.gov.sg/datasets/d_bda4baa634dd1cc7a6c7cad5f19e2d68/view</a:t>
             </a:r>
           </a:p>
           <a:p xmlns:a="http://schemas.openxmlformats.org/drawingml/2006/main">
@@ -1123,7 +1123,7 @@
   </p:cSld>
   <p:clrMap bg1="lt1" tx1="dk1" bg2="lt2" tx2="dk2" accent1="accent1" accent2="accent2" accent3="accent3" accent4="accent4" accent5="accent5" accent6="accent6" hlink="hlink" folHlink="folHlink"/>
   <p:sldLayoutIdLst>
-    <p:sldLayoutId xmlns:r="http://schemas.openxmlformats.org/officeDocument/2006/relationships" id="2147483649" r:id="R57332e01f2d44cf4"/>
+    <p:sldLayoutId xmlns:r="http://schemas.openxmlformats.org/officeDocument/2006/relationships" id="2147483649" r:id="R5f0cb6db25434686"/>
   </p:sldLayoutIdLst>
   <p:txStyles>
     <p:titleStyle>
@@ -1980,7 +1980,7 @@
           <p:cNvPr id="6" name="">
             <a:extLst xmlns:a="http://schemas.openxmlformats.org/drawingml/2006/main">
               <a:ext uri="{FF2B5EF4-FFF2-40B4-BE49-F238E27FC236}">
-                <a16:creationId xmlns:a16="http://schemas.microsoft.com/office/drawing/2014/main" id="{4EE5A8C5-A4AC-432C-950A-7F4920EFF0A1}"/>
+                <a16:creationId xmlns:a16="http://schemas.microsoft.com/office/drawing/2014/main" id="{D4172984-6FB8-4491-A83B-942ABDE8CE37}"/>
               </a:ext>
             </a:extLst>
           </p:cNvPr>
@@ -2037,7 +2037,7 @@
           <p:cNvPr id="2" name="">
             <a:extLst xmlns:a="http://schemas.openxmlformats.org/drawingml/2006/main">
               <a:ext uri="{FF2B5EF4-FFF2-40B4-BE49-F238E27FC236}">
-                <a16:creationId xmlns:a16="http://schemas.microsoft.com/office/drawing/2014/main" id="{8E5963EB-0606-4A1D-A72B-045C601B1718}"/>
+                <a16:creationId xmlns:a16="http://schemas.microsoft.com/office/drawing/2014/main" id="{2018CEC2-ED51-4684-AA9D-6E18C47B0363}"/>
               </a:ext>
             </a:extLst>
           </p:cNvPr>
@@ -2117,7 +2117,7 @@
           <p:cNvPr id="3" name="">
             <a:extLst xmlns:a="http://schemas.openxmlformats.org/drawingml/2006/main">
               <a:ext uri="{FF2B5EF4-FFF2-40B4-BE49-F238E27FC236}">
-                <a16:creationId xmlns:a16="http://schemas.microsoft.com/office/drawing/2014/main" id="{638FB3AF-02C6-40EE-973C-61D3CE86944C}"/>
+                <a16:creationId xmlns:a16="http://schemas.microsoft.com/office/drawing/2014/main" id="{70C5B567-0138-414E-ACAB-E8B46079B83D}"/>
               </a:ext>
             </a:extLst>
           </p:cNvPr>
@@ -2224,7 +2224,7 @@
           <p:nvPr/>
         </p:nvPicPr>
         <p:blipFill>
-          <a:blip xmlns:r="http://schemas.openxmlformats.org/officeDocument/2006/relationships" xmlns:a="http://schemas.openxmlformats.org/drawingml/2006/main" r:embed="R7cd915f6696c428a"/>
+          <a:blip xmlns:r="http://schemas.openxmlformats.org/officeDocument/2006/relationships" xmlns:a="http://schemas.openxmlformats.org/drawingml/2006/main" r:embed="R93181d49eb2448fb"/>
           <a:srcRect xmlns:a="http://schemas.openxmlformats.org/drawingml/2006/main" l="23958" t="0" r="23958" b="0"/>
           <a:stretch xmlns:a="http://schemas.openxmlformats.org/drawingml/2006/main">
             <a:fillRect l="0" t="0" r="0" b="0"/>
@@ -2245,7 +2245,7 @@
           <p:cNvPr id="5" name="">
             <a:extLst xmlns:a="http://schemas.openxmlformats.org/drawingml/2006/main">
               <a:ext uri="{FF2B5EF4-FFF2-40B4-BE49-F238E27FC236}">
-                <a16:creationId xmlns:a16="http://schemas.microsoft.com/office/drawing/2014/main" id="{E81C1E61-2F88-4E98-92C1-6706B2E91D84}"/>
+                <a16:creationId xmlns:a16="http://schemas.microsoft.com/office/drawing/2014/main" id="{75C4845D-7081-47EB-8FD9-79DECB533117}"/>
               </a:ext>
             </a:extLst>
           </p:cNvPr>
@@ -2323,7 +2323,7 @@
     </p:spTree>
     <p:extLst>
       <p:ext uri="{BB962C8B-B14F-4D97-AF65-F5344CB8AC3E}">
-        <p14:creationId xmlns:p14="http://schemas.microsoft.com/office/powerpoint/2010/main" val="1370545969"/>
+        <p14:creationId xmlns:p14="http://schemas.microsoft.com/office/powerpoint/2010/main" val="230599566"/>
       </p:ext>
     </p:extLst>
   </p:cSld>
@@ -2354,7 +2354,7 @@
           <p:cNvPr id="10" name="">
             <a:extLst xmlns:a="http://schemas.openxmlformats.org/drawingml/2006/main">
               <a:ext uri="{FF2B5EF4-FFF2-40B4-BE49-F238E27FC236}">
-                <a16:creationId xmlns:a16="http://schemas.microsoft.com/office/drawing/2014/main" id="{853FB47B-7C82-4F52-B492-BD61D5343B20}"/>
+                <a16:creationId xmlns:a16="http://schemas.microsoft.com/office/drawing/2014/main" id="{26167D93-42AA-4FB7-99FD-EAAA4F6E6639}"/>
               </a:ext>
             </a:extLst>
           </p:cNvPr>
@@ -2411,7 +2411,7 @@
           <p:cNvPr id="2" name="">
             <a:extLst xmlns:a="http://schemas.openxmlformats.org/drawingml/2006/main">
               <a:ext uri="{FF2B5EF4-FFF2-40B4-BE49-F238E27FC236}">
-                <a16:creationId xmlns:a16="http://schemas.microsoft.com/office/drawing/2014/main" id="{3F76BB27-97DB-4A3F-918D-5C306ECF1868}"/>
+                <a16:creationId xmlns:a16="http://schemas.microsoft.com/office/drawing/2014/main" id="{EE7EC243-F2AC-4FA6-A926-E0AF066625DC}"/>
               </a:ext>
             </a:extLst>
           </p:cNvPr>
@@ -2468,7 +2468,7 @@
           <p:cNvPr id="3" name="">
             <a:extLst xmlns:a="http://schemas.openxmlformats.org/drawingml/2006/main">
               <a:ext uri="{FF2B5EF4-FFF2-40B4-BE49-F238E27FC236}">
-                <a16:creationId xmlns:a16="http://schemas.microsoft.com/office/drawing/2014/main" id="{0153DB43-F15C-48E0-AE7A-4707A671EAA1}"/>
+                <a16:creationId xmlns:a16="http://schemas.microsoft.com/office/drawing/2014/main" id="{1C6A40A5-46F2-4953-AD77-7DB91923EBC3}"/>
               </a:ext>
             </a:extLst>
           </p:cNvPr>
@@ -2525,7 +2525,7 @@
           <p:cNvPr id="4" name="">
             <a:extLst xmlns:a="http://schemas.openxmlformats.org/drawingml/2006/main">
               <a:ext uri="{FF2B5EF4-FFF2-40B4-BE49-F238E27FC236}">
-                <a16:creationId xmlns:a16="http://schemas.microsoft.com/office/drawing/2014/main" id="{3B55EB42-6631-45FE-8896-D793B70212B0}"/>
+                <a16:creationId xmlns:a16="http://schemas.microsoft.com/office/drawing/2014/main" id="{DF1085A6-4831-4C5A-B1B2-137D9A891235}"/>
               </a:ext>
             </a:extLst>
           </p:cNvPr>
@@ -2582,7 +2582,7 @@
           <p:cNvPr id="5" name="">
             <a:extLst xmlns:a="http://schemas.openxmlformats.org/drawingml/2006/main">
               <a:ext uri="{FF2B5EF4-FFF2-40B4-BE49-F238E27FC236}">
-                <a16:creationId xmlns:a16="http://schemas.microsoft.com/office/drawing/2014/main" id="{E9BFB8FE-D587-452F-BFB0-6B97693C22DD}"/>
+                <a16:creationId xmlns:a16="http://schemas.microsoft.com/office/drawing/2014/main" id="{9A5CC76F-62AB-4340-9190-EFCE2DFD8CDE}"/>
               </a:ext>
             </a:extLst>
           </p:cNvPr>
@@ -2639,7 +2639,7 @@
           <p:cNvPr id="6" name="">
             <a:extLst xmlns:a="http://schemas.openxmlformats.org/drawingml/2006/main">
               <a:ext uri="{FF2B5EF4-FFF2-40B4-BE49-F238E27FC236}">
-                <a16:creationId xmlns:a16="http://schemas.microsoft.com/office/drawing/2014/main" id="{12BDF29E-333C-4D98-B74C-CDC59B628046}"/>
+                <a16:creationId xmlns:a16="http://schemas.microsoft.com/office/drawing/2014/main" id="{EABAE75C-2F70-4F0E-8D19-C39D92A71381}"/>
               </a:ext>
             </a:extLst>
           </p:cNvPr>
@@ -2696,7 +2696,7 @@
           <p:cNvPr id="7" name="">
             <a:extLst xmlns:a="http://schemas.openxmlformats.org/drawingml/2006/main">
               <a:ext uri="{FF2B5EF4-FFF2-40B4-BE49-F238E27FC236}">
-                <a16:creationId xmlns:a16="http://schemas.microsoft.com/office/drawing/2014/main" id="{FD82D8E4-7D84-4127-BDF1-5C7A889D8A4D}"/>
+                <a16:creationId xmlns:a16="http://schemas.microsoft.com/office/drawing/2014/main" id="{37BAE26E-1968-4283-BF10-3FB0C6E9F328}"/>
               </a:ext>
             </a:extLst>
           </p:cNvPr>
@@ -2753,7 +2753,7 @@
           <p:cNvPr id="8" name="">
             <a:extLst xmlns:a="http://schemas.openxmlformats.org/drawingml/2006/main">
               <a:ext uri="{FF2B5EF4-FFF2-40B4-BE49-F238E27FC236}">
-                <a16:creationId xmlns:a16="http://schemas.microsoft.com/office/drawing/2014/main" id="{2A482C47-6C6F-46AE-B59D-6F2147A8F193}"/>
+                <a16:creationId xmlns:a16="http://schemas.microsoft.com/office/drawing/2014/main" id="{008C20DA-671F-4F2C-BF11-DDBD1C4B9209}"/>
               </a:ext>
             </a:extLst>
           </p:cNvPr>
@@ -2833,7 +2833,7 @@
           <p:cNvPr id="9" name="">
             <a:extLst xmlns:a="http://schemas.openxmlformats.org/drawingml/2006/main">
               <a:ext uri="{FF2B5EF4-FFF2-40B4-BE49-F238E27FC236}">
-                <a16:creationId xmlns:a16="http://schemas.microsoft.com/office/drawing/2014/main" id="{4386EAD3-5791-48C3-AD01-0499A73B289C}"/>
+                <a16:creationId xmlns:a16="http://schemas.microsoft.com/office/drawing/2014/main" id="{5190274C-083E-414F-9907-8A8DC4D9D1E5}"/>
               </a:ext>
             </a:extLst>
           </p:cNvPr>
@@ -2888,7 +2888,7 @@
     </p:spTree>
     <p:extLst>
       <p:ext uri="{BB962C8B-B14F-4D97-AF65-F5344CB8AC3E}">
-        <p14:creationId xmlns:p14="http://schemas.microsoft.com/office/powerpoint/2010/main" val="1945091648"/>
+        <p14:creationId xmlns:p14="http://schemas.microsoft.com/office/powerpoint/2010/main" val="949542453"/>
       </p:ext>
     </p:extLst>
   </p:cSld>
@@ -2919,7 +2919,7 @@
           <p:cNvPr id="9" name="">
             <a:extLst xmlns:a="http://schemas.openxmlformats.org/drawingml/2006/main">
               <a:ext uri="{FF2B5EF4-FFF2-40B4-BE49-F238E27FC236}">
-                <a16:creationId xmlns:a16="http://schemas.microsoft.com/office/drawing/2014/main" id="{C1BC3F4C-3745-4874-9C07-EA07473A44CA}"/>
+                <a16:creationId xmlns:a16="http://schemas.microsoft.com/office/drawing/2014/main" id="{49C4C617-77F9-41CE-9187-43DDCC77103E}"/>
               </a:ext>
             </a:extLst>
           </p:cNvPr>
@@ -2976,7 +2976,7 @@
           <p:cNvPr id="2" name="">
             <a:extLst xmlns:a="http://schemas.openxmlformats.org/drawingml/2006/main">
               <a:ext uri="{FF2B5EF4-FFF2-40B4-BE49-F238E27FC236}">
-                <a16:creationId xmlns:a16="http://schemas.microsoft.com/office/drawing/2014/main" id="{959A0F69-B210-4611-B7A4-02BD9829EA9E}"/>
+                <a16:creationId xmlns:a16="http://schemas.microsoft.com/office/drawing/2014/main" id="{34027477-7D68-4D30-8F20-5B6578674454}"/>
               </a:ext>
             </a:extLst>
           </p:cNvPr>
@@ -3037,7 +3037,7 @@
           <p:nvPr/>
         </p:nvPicPr>
         <p:blipFill>
-          <a:blip xmlns:r="http://schemas.openxmlformats.org/officeDocument/2006/relationships" xmlns:a="http://schemas.openxmlformats.org/drawingml/2006/main" r:embed="R7bf61d40be604b92"/>
+          <a:blip xmlns:r="http://schemas.openxmlformats.org/officeDocument/2006/relationships" xmlns:a="http://schemas.openxmlformats.org/drawingml/2006/main" r:embed="R0d533816c07c4064"/>
           <a:stretch xmlns:a="http://schemas.openxmlformats.org/drawingml/2006/main"/>
         </p:blipFill>
         <p:spPr>
@@ -3055,7 +3055,7 @@
           <p:cNvPr id="4" name="">
             <a:extLst xmlns:a="http://schemas.openxmlformats.org/drawingml/2006/main">
               <a:ext uri="{FF2B5EF4-FFF2-40B4-BE49-F238E27FC236}">
-                <a16:creationId xmlns:a16="http://schemas.microsoft.com/office/drawing/2014/main" id="{26A980EA-AE71-46B5-9C83-8FEE790B525C}"/>
+                <a16:creationId xmlns:a16="http://schemas.microsoft.com/office/drawing/2014/main" id="{3FC0C504-36F1-4C64-AB17-202B1F4A0C3A}"/>
               </a:ext>
             </a:extLst>
           </p:cNvPr>
@@ -3067,7 +3067,7 @@
         <p:spPr>
           <a:xfrm xmlns:a="http://schemas.openxmlformats.org/drawingml/2006/main">
             <a:off x="9010650" y="1524000"/>
-            <a:ext cx="2571750" cy="381000"/>
+            <a:ext cx="2571750" cy="704850"/>
           </a:xfrm>
           <a:prstGeom xmlns:a="http://schemas.openxmlformats.org/drawingml/2006/main" prst="rect">
             <a:avLst/>
@@ -3102,7 +3102,7 @@
                 <a:ea typeface="Helvetica Neue"/>
                 <a:cs typeface="Helvetica Neue"/>
               </a:rPr>
-              <a:t>Select a date</a:t>
+              <a:t>Test cleaning changes</a:t>
             </a:r>
           </a:p>
         </p:txBody>
@@ -3112,7 +3112,7 @@
           <p:cNvPr id="5" name="">
             <a:extLst xmlns:a="http://schemas.openxmlformats.org/drawingml/2006/main">
               <a:ext uri="{FF2B5EF4-FFF2-40B4-BE49-F238E27FC236}">
-                <a16:creationId xmlns:a16="http://schemas.microsoft.com/office/drawing/2014/main" id="{DCF3E695-6EF0-40D2-AEB5-430CC1DAA4E1}"/>
+                <a16:creationId xmlns:a16="http://schemas.microsoft.com/office/drawing/2014/main" id="{159D08A9-87F2-471B-8F4B-D8196C660127}"/>
               </a:ext>
             </a:extLst>
           </p:cNvPr>
@@ -3123,8 +3123,8 @@
         </p:nvSpPr>
         <p:spPr>
           <a:xfrm xmlns:a="http://schemas.openxmlformats.org/drawingml/2006/main">
-            <a:off x="9010650" y="1990725"/>
-            <a:ext cx="2619375" cy="809625"/>
+            <a:off x="9010650" y="2428875"/>
+            <a:ext cx="2619375" cy="1047750"/>
           </a:xfrm>
           <a:prstGeom xmlns:a="http://schemas.openxmlformats.org/drawingml/2006/main" prst="rect">
             <a:avLst/>
@@ -3185,6 +3185,29 @@
               <a:t>hawker coverage</a:t>
             </a:r>
           </a:p>
+          <a:p xmlns:a="http://schemas.openxmlformats.org/drawingml/2006/main">
+            <a:pPr>
+              <a:defRPr sz="1950" b="0">
+                <a:solidFill>
+                  <a:srgbClr val="173D35"/>
+                </a:solidFill>
+                <a:latin typeface="Helvetica Neue"/>
+                <a:ea typeface="Helvetica Neue"/>
+                <a:cs typeface="Helvetica Neue"/>
+              </a:defRPr>
+            </a:pPr>
+            <a:r>
+              <a:rPr sz="1950" b="0">
+                <a:solidFill>
+                  <a:srgbClr val="173D35"/>
+                </a:solidFill>
+                <a:latin typeface="Helvetica Neue"/>
+                <a:ea typeface="Helvetica Neue"/>
+                <a:cs typeface="Helvetica Neue"/>
+              </a:rPr>
+              <a:t>before funding support.</a:t>
+            </a:r>
+          </a:p>
         </p:txBody>
       </p:sp>
       <p:sp>
@@ -3192,7 +3215,7 @@
           <p:cNvPr id="6" name="">
             <a:extLst xmlns:a="http://schemas.openxmlformats.org/drawingml/2006/main">
               <a:ext uri="{FF2B5EF4-FFF2-40B4-BE49-F238E27FC236}">
-                <a16:creationId xmlns:a16="http://schemas.microsoft.com/office/drawing/2014/main" id="{97BE03F4-7849-4861-BAB7-52B22697BFE8}"/>
+                <a16:creationId xmlns:a16="http://schemas.microsoft.com/office/drawing/2014/main" id="{3C1A613F-8774-47A9-885D-F5E9E5C72A64}"/>
               </a:ext>
             </a:extLst>
           </p:cNvPr>
@@ -3203,7 +3226,7 @@
         </p:nvSpPr>
         <p:spPr>
           <a:xfrm xmlns:a="http://schemas.openxmlformats.org/drawingml/2006/main">
-            <a:off x="9010650" y="3067050"/>
+            <a:off x="9010650" y="3714750"/>
             <a:ext cx="2609850" cy="704850"/>
           </a:xfrm>
           <a:prstGeom xmlns:a="http://schemas.openxmlformats.org/drawingml/2006/main" prst="rect">
@@ -3249,7 +3272,7 @@
           <p:cNvPr id="7" name="">
             <a:extLst xmlns:a="http://schemas.openxmlformats.org/drawingml/2006/main">
               <a:ext uri="{FF2B5EF4-FFF2-40B4-BE49-F238E27FC236}">
-                <a16:creationId xmlns:a16="http://schemas.microsoft.com/office/drawing/2014/main" id="{B4BFEF6E-116A-49A5-BF59-19C1629DF30E}"/>
+                <a16:creationId xmlns:a16="http://schemas.microsoft.com/office/drawing/2014/main" id="{B599C818-CCBE-4FBD-9946-54963AD48D5A}"/>
               </a:ext>
             </a:extLst>
           </p:cNvPr>
@@ -3260,7 +3283,7 @@
         </p:nvSpPr>
         <p:spPr>
           <a:xfrm xmlns:a="http://schemas.openxmlformats.org/drawingml/2006/main">
-            <a:off x="9010650" y="3914775"/>
+            <a:off x="9010650" y="4638675"/>
             <a:ext cx="2619375" cy="1047750"/>
           </a:xfrm>
           <a:prstGeom xmlns:a="http://schemas.openxmlformats.org/drawingml/2006/main" prst="rect">
@@ -3352,7 +3375,7 @@
           <p:cNvPr id="8" name="">
             <a:extLst xmlns:a="http://schemas.openxmlformats.org/drawingml/2006/main">
               <a:ext uri="{FF2B5EF4-FFF2-40B4-BE49-F238E27FC236}">
-                <a16:creationId xmlns:a16="http://schemas.microsoft.com/office/drawing/2014/main" id="{0D19D0BB-E56A-4069-8A5A-DA5B445F2177}"/>
+                <a16:creationId xmlns:a16="http://schemas.microsoft.com/office/drawing/2014/main" id="{6DE2789F-D721-49CE-B245-A13D01CCBB7B}"/>
               </a:ext>
             </a:extLst>
           </p:cNvPr>
@@ -3399,7 +3422,7 @@
                 <a:ea typeface="Helvetica Neue"/>
                 <a:cs typeface="Helvetica Neue"/>
               </a:rPr>
-              <a:t>Actual local application. Exposure is an aggregate screening proxy. Other food outlets and individual needs remain unobserved.</a:t>
+              <a:t>Actual local application. Cleaning-date changes are hypothetical. Area exposure is a screening proxy.</a:t>
             </a:r>
           </a:p>
         </p:txBody>
@@ -3407,7 +3430,7 @@
     </p:spTree>
     <p:extLst>
       <p:ext uri="{BB962C8B-B14F-4D97-AF65-F5344CB8AC3E}">
-        <p14:creationId xmlns:p14="http://schemas.microsoft.com/office/powerpoint/2010/main" val="199008082"/>
+        <p14:creationId xmlns:p14="http://schemas.microsoft.com/office/powerpoint/2010/main" val="366348097"/>
       </p:ext>
     </p:extLst>
   </p:cSld>
@@ -3438,7 +3461,7 @@
           <p:cNvPr id="9" name="">
             <a:extLst xmlns:a="http://schemas.openxmlformats.org/drawingml/2006/main">
               <a:ext uri="{FF2B5EF4-FFF2-40B4-BE49-F238E27FC236}">
-                <a16:creationId xmlns:a16="http://schemas.microsoft.com/office/drawing/2014/main" id="{FADBA706-989E-44FD-88E7-ACA238129556}"/>
+                <a16:creationId xmlns:a16="http://schemas.microsoft.com/office/drawing/2014/main" id="{29ABCF9A-2346-4EA1-8082-668C337CB6BC}"/>
               </a:ext>
             </a:extLst>
           </p:cNvPr>
@@ -3495,7 +3518,7 @@
           <p:cNvPr id="2" name="">
             <a:extLst xmlns:a="http://schemas.openxmlformats.org/drawingml/2006/main">
               <a:ext uri="{FF2B5EF4-FFF2-40B4-BE49-F238E27FC236}">
-                <a16:creationId xmlns:a16="http://schemas.microsoft.com/office/drawing/2014/main" id="{F9FCF907-3531-4E95-BC3D-D2A260E60D72}"/>
+                <a16:creationId xmlns:a16="http://schemas.microsoft.com/office/drawing/2014/main" id="{12951C88-A765-4B9B-BE14-90CF3DD19FCF}"/>
               </a:ext>
             </a:extLst>
           </p:cNvPr>
@@ -4019,7 +4042,7 @@
           <p:cNvPr id="4" name="">
             <a:extLst xmlns:a="http://schemas.openxmlformats.org/drawingml/2006/main">
               <a:ext uri="{FF2B5EF4-FFF2-40B4-BE49-F238E27FC236}">
-                <a16:creationId xmlns:a16="http://schemas.microsoft.com/office/drawing/2014/main" id="{BF4B432B-476C-4621-A905-938748737A65}"/>
+                <a16:creationId xmlns:a16="http://schemas.microsoft.com/office/drawing/2014/main" id="{05565357-BF7D-4F41-89D4-27C293259E6B}"/>
               </a:ext>
             </a:extLst>
           </p:cNvPr>
@@ -4076,7 +4099,7 @@
           <p:cNvPr id="5" name="">
             <a:extLst xmlns:a="http://schemas.openxmlformats.org/drawingml/2006/main">
               <a:ext uri="{FF2B5EF4-FFF2-40B4-BE49-F238E27FC236}">
-                <a16:creationId xmlns:a16="http://schemas.microsoft.com/office/drawing/2014/main" id="{352E5B25-C334-42D4-AE0F-1A0A460E730C}"/>
+                <a16:creationId xmlns:a16="http://schemas.microsoft.com/office/drawing/2014/main" id="{3FF46C1F-2D4E-4DC2-A646-96FE4109FEEF}"/>
               </a:ext>
             </a:extLst>
           </p:cNvPr>
@@ -4133,7 +4156,7 @@
           <p:cNvPr id="6" name="">
             <a:extLst xmlns:a="http://schemas.openxmlformats.org/drawingml/2006/main">
               <a:ext uri="{FF2B5EF4-FFF2-40B4-BE49-F238E27FC236}">
-                <a16:creationId xmlns:a16="http://schemas.microsoft.com/office/drawing/2014/main" id="{E2B3CDE9-3839-45D8-BAAB-8164AB5879D4}"/>
+                <a16:creationId xmlns:a16="http://schemas.microsoft.com/office/drawing/2014/main" id="{05FF51ED-DC13-4A81-A125-66B53EA91CB5}"/>
               </a:ext>
             </a:extLst>
           </p:cNvPr>
@@ -4190,7 +4213,7 @@
           <p:cNvPr id="7" name="">
             <a:extLst xmlns:a="http://schemas.openxmlformats.org/drawingml/2006/main">
               <a:ext uri="{FF2B5EF4-FFF2-40B4-BE49-F238E27FC236}">
-                <a16:creationId xmlns:a16="http://schemas.microsoft.com/office/drawing/2014/main" id="{9AA58F34-0CD5-4F19-A7C3-7794EC070EFD}"/>
+                <a16:creationId xmlns:a16="http://schemas.microsoft.com/office/drawing/2014/main" id="{CBFD1DD5-7568-4997-8ED4-CA6FACC223E9}"/>
               </a:ext>
             </a:extLst>
           </p:cNvPr>
@@ -4247,7 +4270,7 @@
           <p:cNvPr id="8" name="">
             <a:extLst xmlns:a="http://schemas.openxmlformats.org/drawingml/2006/main">
               <a:ext uri="{FF2B5EF4-FFF2-40B4-BE49-F238E27FC236}">
-                <a16:creationId xmlns:a16="http://schemas.microsoft.com/office/drawing/2014/main" id="{8EE3A361-1948-45B4-8763-BC10ADEE6952}"/>
+                <a16:creationId xmlns:a16="http://schemas.microsoft.com/office/drawing/2014/main" id="{FBF7D2A8-A6BC-4284-8727-018BBFD3287A}"/>
               </a:ext>
             </a:extLst>
           </p:cNvPr>
@@ -4302,7 +4325,7 @@
     </p:spTree>
     <p:extLst>
       <p:ext uri="{BB962C8B-B14F-4D97-AF65-F5344CB8AC3E}">
-        <p14:creationId xmlns:p14="http://schemas.microsoft.com/office/powerpoint/2010/main" val="457567430"/>
+        <p14:creationId xmlns:p14="http://schemas.microsoft.com/office/powerpoint/2010/main" val="2063714219"/>
       </p:ext>
     </p:extLst>
   </p:cSld>
@@ -4333,7 +4356,7 @@
           <p:cNvPr id="7" name="">
             <a:extLst xmlns:a="http://schemas.openxmlformats.org/drawingml/2006/main">
               <a:ext uri="{FF2B5EF4-FFF2-40B4-BE49-F238E27FC236}">
-                <a16:creationId xmlns:a16="http://schemas.microsoft.com/office/drawing/2014/main" id="{01406A88-1A4F-439B-928E-090695D2B06B}"/>
+                <a16:creationId xmlns:a16="http://schemas.microsoft.com/office/drawing/2014/main" id="{1DE396B6-C053-43EC-97E0-5AA8C09BE8F1}"/>
               </a:ext>
             </a:extLst>
           </p:cNvPr>
@@ -4390,7 +4413,7 @@
           <p:cNvPr id="2" name="">
             <a:extLst xmlns:a="http://schemas.openxmlformats.org/drawingml/2006/main">
               <a:ext uri="{FF2B5EF4-FFF2-40B4-BE49-F238E27FC236}">
-                <a16:creationId xmlns:a16="http://schemas.microsoft.com/office/drawing/2014/main" id="{E618583E-E198-41CA-B4B4-9271AF3A6C8B}"/>
+                <a16:creationId xmlns:a16="http://schemas.microsoft.com/office/drawing/2014/main" id="{7BA9A45F-FE23-4CDF-8570-E432369E6662}"/>
               </a:ext>
             </a:extLst>
           </p:cNvPr>
@@ -4914,7 +4937,7 @@
           <p:cNvPr id="4" name="">
             <a:extLst xmlns:a="http://schemas.openxmlformats.org/drawingml/2006/main">
               <a:ext uri="{FF2B5EF4-FFF2-40B4-BE49-F238E27FC236}">
-                <a16:creationId xmlns:a16="http://schemas.microsoft.com/office/drawing/2014/main" id="{74B398F0-A05A-48BF-BAF3-E9AD68F6D937}"/>
+                <a16:creationId xmlns:a16="http://schemas.microsoft.com/office/drawing/2014/main" id="{84A7C47A-B8DA-4736-83D1-671438E2D20C}"/>
               </a:ext>
             </a:extLst>
           </p:cNvPr>
@@ -4971,7 +4994,7 @@
           <p:cNvPr id="5" name="">
             <a:extLst xmlns:a="http://schemas.openxmlformats.org/drawingml/2006/main">
               <a:ext uri="{FF2B5EF4-FFF2-40B4-BE49-F238E27FC236}">
-                <a16:creationId xmlns:a16="http://schemas.microsoft.com/office/drawing/2014/main" id="{7020B666-59D2-4CA9-A369-794CFAAB8FA6}"/>
+                <a16:creationId xmlns:a16="http://schemas.microsoft.com/office/drawing/2014/main" id="{427C6C6A-6B98-45B7-8E7B-BB1A2A88F214}"/>
               </a:ext>
             </a:extLst>
           </p:cNvPr>
@@ -5028,7 +5051,7 @@
           <p:cNvPr id="6" name="">
             <a:extLst xmlns:a="http://schemas.openxmlformats.org/drawingml/2006/main">
               <a:ext uri="{FF2B5EF4-FFF2-40B4-BE49-F238E27FC236}">
-                <a16:creationId xmlns:a16="http://schemas.microsoft.com/office/drawing/2014/main" id="{10F07223-6DF1-48C3-B6A4-C17070498FB5}"/>
+                <a16:creationId xmlns:a16="http://schemas.microsoft.com/office/drawing/2014/main" id="{E1E936AB-EF24-4B89-B75D-23D8B6758996}"/>
               </a:ext>
             </a:extLst>
           </p:cNvPr>
@@ -5083,7 +5106,7 @@
     </p:spTree>
     <p:extLst>
       <p:ext uri="{BB962C8B-B14F-4D97-AF65-F5344CB8AC3E}">
-        <p14:creationId xmlns:p14="http://schemas.microsoft.com/office/powerpoint/2010/main" val="764030841"/>
+        <p14:creationId xmlns:p14="http://schemas.microsoft.com/office/powerpoint/2010/main" val="1577642337"/>
       </p:ext>
     </p:extLst>
   </p:cSld>
@@ -5114,7 +5137,7 @@
           <p:cNvPr id="10" name="">
             <a:extLst xmlns:a="http://schemas.openxmlformats.org/drawingml/2006/main">
               <a:ext uri="{FF2B5EF4-FFF2-40B4-BE49-F238E27FC236}">
-                <a16:creationId xmlns:a16="http://schemas.microsoft.com/office/drawing/2014/main" id="{64022910-008D-4FC3-8EA6-4A6A559EABF1}"/>
+                <a16:creationId xmlns:a16="http://schemas.microsoft.com/office/drawing/2014/main" id="{92522CE5-4570-4CD1-A8C2-6EAAC1F20659}"/>
               </a:ext>
             </a:extLst>
           </p:cNvPr>
@@ -5171,7 +5194,7 @@
           <p:cNvPr id="2" name="">
             <a:extLst xmlns:a="http://schemas.openxmlformats.org/drawingml/2006/main">
               <a:ext uri="{FF2B5EF4-FFF2-40B4-BE49-F238E27FC236}">
-                <a16:creationId xmlns:a16="http://schemas.microsoft.com/office/drawing/2014/main" id="{8A41E2E3-437A-4D14-93F3-3D34E6BA3D0F}"/>
+                <a16:creationId xmlns:a16="http://schemas.microsoft.com/office/drawing/2014/main" id="{49D42DB1-E023-4F1C-8459-BC329BE4344F}"/>
               </a:ext>
             </a:extLst>
           </p:cNvPr>
@@ -5228,7 +5251,7 @@
           <p:cNvPr id="3" name="">
             <a:extLst xmlns:a="http://schemas.openxmlformats.org/drawingml/2006/main">
               <a:ext uri="{FF2B5EF4-FFF2-40B4-BE49-F238E27FC236}">
-                <a16:creationId xmlns:a16="http://schemas.microsoft.com/office/drawing/2014/main" id="{58336C12-F5FB-4E57-A617-B7F7606E5B1F}"/>
+                <a16:creationId xmlns:a16="http://schemas.microsoft.com/office/drawing/2014/main" id="{1D21F369-BBF3-48EB-B144-3C4D43423683}"/>
               </a:ext>
             </a:extLst>
           </p:cNvPr>
@@ -5292,7 +5315,7 @@
         </p:xfrm>
         <a:graphic xmlns:a="http://schemas.openxmlformats.org/drawingml/2006/main">
           <a:graphicData uri="http://schemas.openxmlformats.org/drawingml/2006/chart">
-            <c:chart xmlns:r="http://schemas.openxmlformats.org/officeDocument/2006/relationships" xmlns:c="http://schemas.openxmlformats.org/drawingml/2006/chart" r:id="R87fbd4bd858f4423"/>
+            <c:chart xmlns:r="http://schemas.openxmlformats.org/officeDocument/2006/relationships" xmlns:c="http://schemas.openxmlformats.org/drawingml/2006/chart" r:id="Rdb26119152da43ee"/>
           </a:graphicData>
         </a:graphic>
       </p:graphicFrame>
@@ -5301,7 +5324,7 @@
           <p:cNvPr id="5" name="">
             <a:extLst xmlns:a="http://schemas.openxmlformats.org/drawingml/2006/main">
               <a:ext uri="{FF2B5EF4-FFF2-40B4-BE49-F238E27FC236}">
-                <a16:creationId xmlns:a16="http://schemas.microsoft.com/office/drawing/2014/main" id="{D08AC442-ECF2-413B-87F4-4E7AC1DD2881}"/>
+                <a16:creationId xmlns:a16="http://schemas.microsoft.com/office/drawing/2014/main" id="{C3261FF6-B222-464E-8C62-3D8D06795DDB}"/>
               </a:ext>
             </a:extLst>
           </p:cNvPr>
@@ -5358,7 +5381,7 @@
           <p:cNvPr id="6" name="">
             <a:extLst xmlns:a="http://schemas.openxmlformats.org/drawingml/2006/main">
               <a:ext uri="{FF2B5EF4-FFF2-40B4-BE49-F238E27FC236}">
-                <a16:creationId xmlns:a16="http://schemas.microsoft.com/office/drawing/2014/main" id="{38A1FBBA-E4E5-46A4-AA29-426C184D0B9F}"/>
+                <a16:creationId xmlns:a16="http://schemas.microsoft.com/office/drawing/2014/main" id="{BE7CB778-24E4-4B48-A608-29FE05673EB2}"/>
               </a:ext>
             </a:extLst>
           </p:cNvPr>
@@ -5438,7 +5461,7 @@
           <p:cNvPr id="7" name="">
             <a:extLst xmlns:a="http://schemas.openxmlformats.org/drawingml/2006/main">
               <a:ext uri="{FF2B5EF4-FFF2-40B4-BE49-F238E27FC236}">
-                <a16:creationId xmlns:a16="http://schemas.microsoft.com/office/drawing/2014/main" id="{4053F8AD-A2A5-44CD-A70D-6E5BF9B655B6}"/>
+                <a16:creationId xmlns:a16="http://schemas.microsoft.com/office/drawing/2014/main" id="{37EF52D3-6FBB-40D1-A22A-3EDC8EFF832F}"/>
               </a:ext>
             </a:extLst>
           </p:cNvPr>
@@ -5541,7 +5564,7 @@
           <p:cNvPr id="8" name="">
             <a:extLst xmlns:a="http://schemas.openxmlformats.org/drawingml/2006/main">
               <a:ext uri="{FF2B5EF4-FFF2-40B4-BE49-F238E27FC236}">
-                <a16:creationId xmlns:a16="http://schemas.microsoft.com/office/drawing/2014/main" id="{FD850D3E-C087-415F-BD64-290DAE0EE012}"/>
+                <a16:creationId xmlns:a16="http://schemas.microsoft.com/office/drawing/2014/main" id="{874799C4-A207-48F9-B8BC-3C1469F9460C}"/>
               </a:ext>
             </a:extLst>
           </p:cNvPr>
@@ -5598,7 +5621,7 @@
           <p:cNvPr id="9" name="">
             <a:extLst xmlns:a="http://schemas.openxmlformats.org/drawingml/2006/main">
               <a:ext uri="{FF2B5EF4-FFF2-40B4-BE49-F238E27FC236}">
-                <a16:creationId xmlns:a16="http://schemas.microsoft.com/office/drawing/2014/main" id="{06083664-48C5-4B55-8E5F-7AF2D17457B9}"/>
+                <a16:creationId xmlns:a16="http://schemas.microsoft.com/office/drawing/2014/main" id="{DC1B2F0E-196F-4B97-9922-06C20DC49395}"/>
               </a:ext>
             </a:extLst>
           </p:cNvPr>
@@ -5653,7 +5676,7 @@
     </p:spTree>
     <p:extLst>
       <p:ext uri="{BB962C8B-B14F-4D97-AF65-F5344CB8AC3E}">
-        <p14:creationId xmlns:p14="http://schemas.microsoft.com/office/powerpoint/2010/main" val="344968260"/>
+        <p14:creationId xmlns:p14="http://schemas.microsoft.com/office/powerpoint/2010/main" val="444170366"/>
       </p:ext>
     </p:extLst>
   </p:cSld>
@@ -5684,7 +5707,7 @@
           <p:cNvPr id="9" name="">
             <a:extLst xmlns:a="http://schemas.openxmlformats.org/drawingml/2006/main">
               <a:ext uri="{FF2B5EF4-FFF2-40B4-BE49-F238E27FC236}">
-                <a16:creationId xmlns:a16="http://schemas.microsoft.com/office/drawing/2014/main" id="{61BCB9D4-414D-4A8D-8BCD-C01F9B633023}"/>
+                <a16:creationId xmlns:a16="http://schemas.microsoft.com/office/drawing/2014/main" id="{AF59CBC9-AFCA-4CD2-9284-4EC3AF055999}"/>
               </a:ext>
             </a:extLst>
           </p:cNvPr>
@@ -5741,7 +5764,7 @@
           <p:cNvPr id="2" name="">
             <a:extLst xmlns:a="http://schemas.openxmlformats.org/drawingml/2006/main">
               <a:ext uri="{FF2B5EF4-FFF2-40B4-BE49-F238E27FC236}">
-                <a16:creationId xmlns:a16="http://schemas.microsoft.com/office/drawing/2014/main" id="{6745C18D-39FD-4042-9CD4-38325BD23445}"/>
+                <a16:creationId xmlns:a16="http://schemas.microsoft.com/office/drawing/2014/main" id="{CF8DA1B8-F71A-4244-B864-4E7AF8F70699}"/>
               </a:ext>
             </a:extLst>
           </p:cNvPr>
@@ -5802,7 +5825,7 @@
           <p:nvPr/>
         </p:nvPicPr>
         <p:blipFill>
-          <a:blip xmlns:r="http://schemas.openxmlformats.org/officeDocument/2006/relationships" xmlns:a="http://schemas.openxmlformats.org/drawingml/2006/main" r:embed="R4dd287a75f1643b0"/>
+          <a:blip xmlns:r="http://schemas.openxmlformats.org/officeDocument/2006/relationships" xmlns:a="http://schemas.openxmlformats.org/drawingml/2006/main" r:embed="R40346475b00a4d9b"/>
           <a:stretch xmlns:a="http://schemas.openxmlformats.org/drawingml/2006/main"/>
         </p:blipFill>
         <p:spPr>
@@ -5820,7 +5843,7 @@
           <p:cNvPr id="4" name="">
             <a:extLst xmlns:a="http://schemas.openxmlformats.org/drawingml/2006/main">
               <a:ext uri="{FF2B5EF4-FFF2-40B4-BE49-F238E27FC236}">
-                <a16:creationId xmlns:a16="http://schemas.microsoft.com/office/drawing/2014/main" id="{F72F0FCC-D510-42E2-BC0E-B617F3F43B59}"/>
+                <a16:creationId xmlns:a16="http://schemas.microsoft.com/office/drawing/2014/main" id="{6B425C03-6CA1-4CAB-B514-4F5AE3B121C0}"/>
               </a:ext>
             </a:extLst>
           </p:cNvPr>
@@ -5877,7 +5900,7 @@
           <p:cNvPr id="5" name="">
             <a:extLst xmlns:a="http://schemas.openxmlformats.org/drawingml/2006/main">
               <a:ext uri="{FF2B5EF4-FFF2-40B4-BE49-F238E27FC236}">
-                <a16:creationId xmlns:a16="http://schemas.microsoft.com/office/drawing/2014/main" id="{03AF1096-BD9C-4E66-AB07-E3B13D7C011C}"/>
+                <a16:creationId xmlns:a16="http://schemas.microsoft.com/office/drawing/2014/main" id="{BEB9B0DD-87F2-4970-84CC-E5CEC6B32A54}"/>
               </a:ext>
             </a:extLst>
           </p:cNvPr>
@@ -5957,7 +5980,7 @@
           <p:cNvPr id="6" name="">
             <a:extLst xmlns:a="http://schemas.openxmlformats.org/drawingml/2006/main">
               <a:ext uri="{FF2B5EF4-FFF2-40B4-BE49-F238E27FC236}">
-                <a16:creationId xmlns:a16="http://schemas.microsoft.com/office/drawing/2014/main" id="{AEF9ADD7-A1F1-4534-AFF7-31B4F30E0922}"/>
+                <a16:creationId xmlns:a16="http://schemas.microsoft.com/office/drawing/2014/main" id="{E0B54E39-E1FF-4C3D-89C9-8F7998E4BAC4}"/>
               </a:ext>
             </a:extLst>
           </p:cNvPr>
@@ -6037,7 +6060,7 @@
           <p:cNvPr id="7" name="">
             <a:extLst xmlns:a="http://schemas.openxmlformats.org/drawingml/2006/main">
               <a:ext uri="{FF2B5EF4-FFF2-40B4-BE49-F238E27FC236}">
-                <a16:creationId xmlns:a16="http://schemas.microsoft.com/office/drawing/2014/main" id="{D9DBF18C-C6B2-4A56-A15F-2C4FB5FE24A5}"/>
+                <a16:creationId xmlns:a16="http://schemas.microsoft.com/office/drawing/2014/main" id="{1E45857B-E419-407A-9F6C-CBD3A3914126}"/>
               </a:ext>
             </a:extLst>
           </p:cNvPr>
@@ -6117,7 +6140,7 @@
           <p:cNvPr id="8" name="">
             <a:extLst xmlns:a="http://schemas.openxmlformats.org/drawingml/2006/main">
               <a:ext uri="{FF2B5EF4-FFF2-40B4-BE49-F238E27FC236}">
-                <a16:creationId xmlns:a16="http://schemas.microsoft.com/office/drawing/2014/main" id="{C4F81361-EBF6-492B-A57E-66182B7F8898}"/>
+                <a16:creationId xmlns:a16="http://schemas.microsoft.com/office/drawing/2014/main" id="{F9D90F1F-9BCC-4680-B642-4FF1C052D151}"/>
               </a:ext>
             </a:extLst>
           </p:cNvPr>
@@ -6172,7 +6195,7 @@
     </p:spTree>
     <p:extLst>
       <p:ext uri="{BB962C8B-B14F-4D97-AF65-F5344CB8AC3E}">
-        <p14:creationId xmlns:p14="http://schemas.microsoft.com/office/powerpoint/2010/main" val="370640989"/>
+        <p14:creationId xmlns:p14="http://schemas.microsoft.com/office/powerpoint/2010/main" val="321434030"/>
       </p:ext>
     </p:extLst>
   </p:cSld>
@@ -6203,7 +6226,7 @@
           <p:cNvPr id="12" name="">
             <a:extLst xmlns:a="http://schemas.openxmlformats.org/drawingml/2006/main">
               <a:ext uri="{FF2B5EF4-FFF2-40B4-BE49-F238E27FC236}">
-                <a16:creationId xmlns:a16="http://schemas.microsoft.com/office/drawing/2014/main" id="{B719648A-5620-4F54-B396-D20D87ED8597}"/>
+                <a16:creationId xmlns:a16="http://schemas.microsoft.com/office/drawing/2014/main" id="{2E2198B9-D8D6-4F70-B90E-D08DC75B5AC0}"/>
               </a:ext>
             </a:extLst>
           </p:cNvPr>
@@ -6260,7 +6283,7 @@
           <p:cNvPr id="2" name="">
             <a:extLst xmlns:a="http://schemas.openxmlformats.org/drawingml/2006/main">
               <a:ext uri="{FF2B5EF4-FFF2-40B4-BE49-F238E27FC236}">
-                <a16:creationId xmlns:a16="http://schemas.microsoft.com/office/drawing/2014/main" id="{9BFCFB4B-A44A-4BE2-A539-FB01A6AC0120}"/>
+                <a16:creationId xmlns:a16="http://schemas.microsoft.com/office/drawing/2014/main" id="{BBEB27B8-60B0-4F70-90E2-5D76CAE2B85C}"/>
               </a:ext>
             </a:extLst>
           </p:cNvPr>
@@ -6317,7 +6340,7 @@
           <p:cNvPr id="3" name="">
             <a:extLst xmlns:a="http://schemas.openxmlformats.org/drawingml/2006/main">
               <a:ext uri="{FF2B5EF4-FFF2-40B4-BE49-F238E27FC236}">
-                <a16:creationId xmlns:a16="http://schemas.microsoft.com/office/drawing/2014/main" id="{A3FC64D9-074D-4E73-BF25-5050C114E011}"/>
+                <a16:creationId xmlns:a16="http://schemas.microsoft.com/office/drawing/2014/main" id="{21B2E020-8B57-431D-9268-25564837357F}"/>
               </a:ext>
             </a:extLst>
           </p:cNvPr>
@@ -6374,7 +6397,7 @@
           <p:cNvPr id="4" name="">
             <a:extLst xmlns:a="http://schemas.openxmlformats.org/drawingml/2006/main">
               <a:ext uri="{FF2B5EF4-FFF2-40B4-BE49-F238E27FC236}">
-                <a16:creationId xmlns:a16="http://schemas.microsoft.com/office/drawing/2014/main" id="{C0C168A1-1AA0-43C2-88F8-9A882D05E9CD}"/>
+                <a16:creationId xmlns:a16="http://schemas.microsoft.com/office/drawing/2014/main" id="{1DDE230E-B509-4D98-BA83-B3D97E4AA1F9}"/>
               </a:ext>
             </a:extLst>
           </p:cNvPr>
@@ -6454,7 +6477,7 @@
           <p:cNvPr id="5" name="">
             <a:extLst xmlns:a="http://schemas.openxmlformats.org/drawingml/2006/main">
               <a:ext uri="{FF2B5EF4-FFF2-40B4-BE49-F238E27FC236}">
-                <a16:creationId xmlns:a16="http://schemas.microsoft.com/office/drawing/2014/main" id="{F417EC99-181A-4505-A510-4FC6B03F7866}"/>
+                <a16:creationId xmlns:a16="http://schemas.microsoft.com/office/drawing/2014/main" id="{9808568D-88A1-4A50-9B65-75AC2E743D58}"/>
               </a:ext>
             </a:extLst>
           </p:cNvPr>
@@ -6534,7 +6557,7 @@
           <p:cNvPr id="6" name="">
             <a:extLst xmlns:a="http://schemas.openxmlformats.org/drawingml/2006/main">
               <a:ext uri="{FF2B5EF4-FFF2-40B4-BE49-F238E27FC236}">
-                <a16:creationId xmlns:a16="http://schemas.microsoft.com/office/drawing/2014/main" id="{6BC01B57-9BE6-4C9D-8D23-688F33046E17}"/>
+                <a16:creationId xmlns:a16="http://schemas.microsoft.com/office/drawing/2014/main" id="{20FE1F88-E79E-4E59-A8CF-471B46F65E16}"/>
               </a:ext>
             </a:extLst>
           </p:cNvPr>
@@ -6591,7 +6614,7 @@
           <p:cNvPr id="7" name="">
             <a:extLst xmlns:a="http://schemas.openxmlformats.org/drawingml/2006/main">
               <a:ext uri="{FF2B5EF4-FFF2-40B4-BE49-F238E27FC236}">
-                <a16:creationId xmlns:a16="http://schemas.microsoft.com/office/drawing/2014/main" id="{A0F84591-670A-42CB-BD2C-869227404339}"/>
+                <a16:creationId xmlns:a16="http://schemas.microsoft.com/office/drawing/2014/main" id="{E7AB3448-BACA-4FB5-8F1D-CEC91073152C}"/>
               </a:ext>
             </a:extLst>
           </p:cNvPr>
@@ -6648,7 +6671,7 @@
           <p:cNvPr id="8" name="">
             <a:extLst xmlns:a="http://schemas.openxmlformats.org/drawingml/2006/main">
               <a:ext uri="{FF2B5EF4-FFF2-40B4-BE49-F238E27FC236}">
-                <a16:creationId xmlns:a16="http://schemas.microsoft.com/office/drawing/2014/main" id="{510D9F79-2323-4359-844D-5F8B9D83FE55}"/>
+                <a16:creationId xmlns:a16="http://schemas.microsoft.com/office/drawing/2014/main" id="{2D7F2736-1CE1-462C-8008-762F5C634CFA}"/>
               </a:ext>
             </a:extLst>
           </p:cNvPr>
@@ -6705,7 +6728,7 @@
           <p:cNvPr id="9" name="">
             <a:extLst xmlns:a="http://schemas.openxmlformats.org/drawingml/2006/main">
               <a:ext uri="{FF2B5EF4-FFF2-40B4-BE49-F238E27FC236}">
-                <a16:creationId xmlns:a16="http://schemas.microsoft.com/office/drawing/2014/main" id="{E3AC755E-3E25-4508-844B-173A5610AE48}"/>
+                <a16:creationId xmlns:a16="http://schemas.microsoft.com/office/drawing/2014/main" id="{DA4579BA-BBF1-4A0E-B48F-78D5BA6E2B2A}"/>
               </a:ext>
             </a:extLst>
           </p:cNvPr>
@@ -6785,7 +6808,7 @@
           <p:cNvPr id="10" name="">
             <a:extLst xmlns:a="http://schemas.openxmlformats.org/drawingml/2006/main">
               <a:ext uri="{FF2B5EF4-FFF2-40B4-BE49-F238E27FC236}">
-                <a16:creationId xmlns:a16="http://schemas.microsoft.com/office/drawing/2014/main" id="{68FFF16C-EF33-49C2-986B-E61A3360A436}"/>
+                <a16:creationId xmlns:a16="http://schemas.microsoft.com/office/drawing/2014/main" id="{BEC64649-EAA6-4FFD-898A-789823C8DFFC}"/>
               </a:ext>
             </a:extLst>
           </p:cNvPr>
@@ -6865,7 +6888,7 @@
           <p:cNvPr id="11" name="">
             <a:extLst xmlns:a="http://schemas.openxmlformats.org/drawingml/2006/main">
               <a:ext uri="{FF2B5EF4-FFF2-40B4-BE49-F238E27FC236}">
-                <a16:creationId xmlns:a16="http://schemas.microsoft.com/office/drawing/2014/main" id="{1128A813-06DB-4746-8F6A-2F02DCEC8DEE}"/>
+                <a16:creationId xmlns:a16="http://schemas.microsoft.com/office/drawing/2014/main" id="{2C272B3E-C05B-4C16-9BA5-B630B8D5DA1E}"/>
               </a:ext>
             </a:extLst>
           </p:cNvPr>
@@ -6920,7 +6943,7 @@
     </p:spTree>
     <p:extLst>
       <p:ext uri="{BB962C8B-B14F-4D97-AF65-F5344CB8AC3E}">
-        <p14:creationId xmlns:p14="http://schemas.microsoft.com/office/powerpoint/2010/main" val="2001175530"/>
+        <p14:creationId xmlns:p14="http://schemas.microsoft.com/office/powerpoint/2010/main" val="2055076581"/>
       </p:ext>
     </p:extLst>
   </p:cSld>
@@ -6951,7 +6974,7 @@
           <p:cNvPr id="9" name="">
             <a:extLst xmlns:a="http://schemas.openxmlformats.org/drawingml/2006/main">
               <a:ext uri="{FF2B5EF4-FFF2-40B4-BE49-F238E27FC236}">
-                <a16:creationId xmlns:a16="http://schemas.microsoft.com/office/drawing/2014/main" id="{741BC060-BBFF-4634-A77E-071E2DC9947E}"/>
+                <a16:creationId xmlns:a16="http://schemas.microsoft.com/office/drawing/2014/main" id="{01F516E3-1DB3-4193-B1B3-F3DF509DA656}"/>
               </a:ext>
             </a:extLst>
           </p:cNvPr>
@@ -7008,7 +7031,7 @@
           <p:cNvPr id="2" name="">
             <a:extLst xmlns:a="http://schemas.openxmlformats.org/drawingml/2006/main">
               <a:ext uri="{FF2B5EF4-FFF2-40B4-BE49-F238E27FC236}">
-                <a16:creationId xmlns:a16="http://schemas.microsoft.com/office/drawing/2014/main" id="{6501B879-E9BC-4232-A289-CC1F632BF399}"/>
+                <a16:creationId xmlns:a16="http://schemas.microsoft.com/office/drawing/2014/main" id="{92046CFD-87EB-4157-8F65-56F083A5FF6B}"/>
               </a:ext>
             </a:extLst>
           </p:cNvPr>
@@ -7065,7 +7088,7 @@
           <p:cNvPr id="3" name="">
             <a:extLst xmlns:a="http://schemas.openxmlformats.org/drawingml/2006/main">
               <a:ext uri="{FF2B5EF4-FFF2-40B4-BE49-F238E27FC236}">
-                <a16:creationId xmlns:a16="http://schemas.microsoft.com/office/drawing/2014/main" id="{F20DBEB9-930F-4E6B-9C95-C5050F57AEFD}"/>
+                <a16:creationId xmlns:a16="http://schemas.microsoft.com/office/drawing/2014/main" id="{4B57557C-4ED6-46D2-B642-512FD14FA1CB}"/>
               </a:ext>
             </a:extLst>
           </p:cNvPr>
@@ -7168,7 +7191,7 @@
           <p:cNvPr id="4" name="">
             <a:extLst xmlns:a="http://schemas.openxmlformats.org/drawingml/2006/main">
               <a:ext uri="{FF2B5EF4-FFF2-40B4-BE49-F238E27FC236}">
-                <a16:creationId xmlns:a16="http://schemas.microsoft.com/office/drawing/2014/main" id="{BE055BF9-3E51-45D1-91EC-9F7BB9FCC6CA}"/>
+                <a16:creationId xmlns:a16="http://schemas.microsoft.com/office/drawing/2014/main" id="{E7FF5C0E-A64C-44E8-B347-0469BF89F70E}"/>
               </a:ext>
             </a:extLst>
           </p:cNvPr>
@@ -7225,7 +7248,7 @@
           <p:cNvPr id="5" name="">
             <a:extLst xmlns:a="http://schemas.openxmlformats.org/drawingml/2006/main">
               <a:ext uri="{FF2B5EF4-FFF2-40B4-BE49-F238E27FC236}">
-                <a16:creationId xmlns:a16="http://schemas.microsoft.com/office/drawing/2014/main" id="{1C7238DF-3A5A-40B6-A532-D0A972257CF2}"/>
+                <a16:creationId xmlns:a16="http://schemas.microsoft.com/office/drawing/2014/main" id="{32102284-871A-406B-A968-27D80621D781}"/>
               </a:ext>
             </a:extLst>
           </p:cNvPr>
@@ -7282,7 +7305,7 @@
           <p:cNvPr id="6" name="">
             <a:extLst xmlns:a="http://schemas.openxmlformats.org/drawingml/2006/main">
               <a:ext uri="{FF2B5EF4-FFF2-40B4-BE49-F238E27FC236}">
-                <a16:creationId xmlns:a16="http://schemas.microsoft.com/office/drawing/2014/main" id="{6BD2C406-B05E-4D0C-9BBF-CCA419A829D4}"/>
+                <a16:creationId xmlns:a16="http://schemas.microsoft.com/office/drawing/2014/main" id="{1039E944-0972-4934-92E5-183E7F27D940}"/>
               </a:ext>
             </a:extLst>
           </p:cNvPr>
@@ -7362,7 +7385,7 @@
           <p:cNvPr id="7" name="">
             <a:extLst xmlns:a="http://schemas.openxmlformats.org/drawingml/2006/main">
               <a:ext uri="{FF2B5EF4-FFF2-40B4-BE49-F238E27FC236}">
-                <a16:creationId xmlns:a16="http://schemas.microsoft.com/office/drawing/2014/main" id="{CD78333B-8462-4DDC-BE5B-E0EC9F4E6090}"/>
+                <a16:creationId xmlns:a16="http://schemas.microsoft.com/office/drawing/2014/main" id="{0B4100A3-B908-4344-8CC0-7A8B828335A6}"/>
               </a:ext>
             </a:extLst>
           </p:cNvPr>
@@ -7442,7 +7465,7 @@
           <p:cNvPr id="8" name="">
             <a:extLst xmlns:a="http://schemas.openxmlformats.org/drawingml/2006/main">
               <a:ext uri="{FF2B5EF4-FFF2-40B4-BE49-F238E27FC236}">
-                <a16:creationId xmlns:a16="http://schemas.microsoft.com/office/drawing/2014/main" id="{64C51DA6-B628-4997-9FCC-2FCDCA971E84}"/>
+                <a16:creationId xmlns:a16="http://schemas.microsoft.com/office/drawing/2014/main" id="{507BC988-A09B-4306-95E1-A130592857C3}"/>
               </a:ext>
             </a:extLst>
           </p:cNvPr>
@@ -7497,7 +7520,7 @@
     </p:spTree>
     <p:extLst>
       <p:ext uri="{BB962C8B-B14F-4D97-AF65-F5344CB8AC3E}">
-        <p14:creationId xmlns:p14="http://schemas.microsoft.com/office/powerpoint/2010/main" val="2060532278"/>
+        <p14:creationId xmlns:p14="http://schemas.microsoft.com/office/powerpoint/2010/main" val="718187142"/>
       </p:ext>
     </p:extLst>
   </p:cSld>

</xml_diff>

<commit_message>
Wait for hosted initial analysis before asserting dashboard readiness
</commit_message>
<xml_diff>
--- a/output/presentations/hawkerbridge-final-pitch.pptx
+++ b/output/presentations/hawkerbridge-final-pitch.pptx
@@ -2,21 +2,21 @@
 <file path=ppt/presentation.xml><?xml version="1.0" encoding="utf-8"?>
 <p:presentation xmlns:p="http://schemas.openxmlformats.org/presentationml/2006/main">
   <p:sldMasterIdLst>
-    <p:sldMasterId xmlns:r="http://schemas.openxmlformats.org/officeDocument/2006/relationships" id="2147483648" r:id="R3444339f307942ad"/>
+    <p:sldMasterId xmlns:r="http://schemas.openxmlformats.org/officeDocument/2006/relationships" id="2147483648" r:id="Rf47369c8ed1e4716"/>
   </p:sldMasterIdLst>
   <p:notesMasterIdLst>
-    <p:notesMasterId xmlns:r="http://schemas.openxmlformats.org/officeDocument/2006/relationships" r:id="Rc76b4fb64d994445"/>
+    <p:notesMasterId xmlns:r="http://schemas.openxmlformats.org/officeDocument/2006/relationships" r:id="R7933046ea8244c46"/>
   </p:notesMasterIdLst>
   <p:sldIdLst>
-    <p:sldId xmlns:r="http://schemas.openxmlformats.org/officeDocument/2006/relationships" id="256" r:id="R291de8099a5e419a"/>
-    <p:sldId xmlns:r="http://schemas.openxmlformats.org/officeDocument/2006/relationships" id="257" r:id="R87302f453ca8404d"/>
-    <p:sldId xmlns:r="http://schemas.openxmlformats.org/officeDocument/2006/relationships" id="258" r:id="Re3d59d71ec5a4af6"/>
-    <p:sldId xmlns:r="http://schemas.openxmlformats.org/officeDocument/2006/relationships" id="259" r:id="R23863fc36ec6401c"/>
-    <p:sldId xmlns:r="http://schemas.openxmlformats.org/officeDocument/2006/relationships" id="260" r:id="R0bdbd60fc2164212"/>
-    <p:sldId xmlns:r="http://schemas.openxmlformats.org/officeDocument/2006/relationships" id="261" r:id="Rdaa9dd89bbaf4b62"/>
-    <p:sldId xmlns:r="http://schemas.openxmlformats.org/officeDocument/2006/relationships" id="262" r:id="R3d2829ccf4614acd"/>
-    <p:sldId xmlns:r="http://schemas.openxmlformats.org/officeDocument/2006/relationships" id="263" r:id="R3ef7cddf3507447b"/>
-    <p:sldId xmlns:r="http://schemas.openxmlformats.org/officeDocument/2006/relationships" id="264" r:id="Rc41e24307da14fe2"/>
+    <p:sldId xmlns:r="http://schemas.openxmlformats.org/officeDocument/2006/relationships" id="256" r:id="Rbebf9d24b4df4bf1"/>
+    <p:sldId xmlns:r="http://schemas.openxmlformats.org/officeDocument/2006/relationships" id="257" r:id="R8dc496c33d574cef"/>
+    <p:sldId xmlns:r="http://schemas.openxmlformats.org/officeDocument/2006/relationships" id="258" r:id="Rcdcbb0d6d5ec4424"/>
+    <p:sldId xmlns:r="http://schemas.openxmlformats.org/officeDocument/2006/relationships" id="259" r:id="R2bddf9856dee45cb"/>
+    <p:sldId xmlns:r="http://schemas.openxmlformats.org/officeDocument/2006/relationships" id="260" r:id="R4e4290182e8f4ec1"/>
+    <p:sldId xmlns:r="http://schemas.openxmlformats.org/officeDocument/2006/relationships" id="261" r:id="Rb6df401daa504e9a"/>
+    <p:sldId xmlns:r="http://schemas.openxmlformats.org/officeDocument/2006/relationships" id="262" r:id="Ra1d38f0ea6e844f2"/>
+    <p:sldId xmlns:r="http://schemas.openxmlformats.org/officeDocument/2006/relationships" id="263" r:id="R2b11f05009454d16"/>
+    <p:sldId xmlns:r="http://schemas.openxmlformats.org/officeDocument/2006/relationships" id="264" r:id="Rc880195393cf4da4"/>
   </p:sldIdLst>
   <p:sldSz cx="12192000" cy="6858000"/>
   <p:notesSz cx="6858000" cy="9144000"/>
@@ -775,7 +775,7 @@
           <a:lstStyle xmlns:a="http://schemas.openxmlformats.org/drawingml/2006/main"/>
           <a:p xmlns:a="http://schemas.openxmlformats.org/drawingml/2006/main">
             <a:r>
-              <a:t>Implemented code: databricks/notebooks/01_pipeline.py, databricks.yml, resources/, backend/hawkerbridge/databricks_store.py and docs/databricks-deployment.md. Execution status at deck build: {"local_app_tested":true,"databricks_workspace_execution_verified":false,"databricks_app_url":null,"successful_pipeline_run_url":null,"mlflow_run_url":null,"public_or_unlisted_video_url":null,"note":"This records actual evidence, not intended architecture. Populate cloud links only after successful workspace execution."}. Unity Catalog governance and explicit lineage records are implemented. Do not claim unverified automatic column lineage. Publication uses staging plus a final pointer record, not cross-table ACID. Archived replay is explicitly labeled if used. Cloud mode fails closed rather than silently displaying local data. Free Edition limitations: https://docs.databricks.com/aws/en/getting-started/free-edition-limitations .</a:t>
+              <a:t>Implemented code: databricks/notebooks/01_pipeline.py, databricks.yml, resources/, backend/hawkerbridge/databricks_store.py and docs/databricks-deployment.md. Execution status at deck build: {"local_app_tested":true,"databricks_workspace_execution_verified":true,"databricks_app_url":"https://hawkerbridge-7474659582484876.aws.databricksapps.com","successful_pipeline_run_url":"https://dbc-6fea141d-04eb.cloud.databricks.com/jobs/929729986607018/runs/1046237288082887?o=7474659582484876","mlflow_run_url":"https://dbc-6fea141d-04eb.cloud.databricks.com/ml/experiments/2274018642838106/runs/6b80647b3eea44d5bf9af59c315eec66","public_or_unlisted_video_url":null,"note":"This records actual evidence, not intended architecture. Populate cloud links only after successful workspace execution.","local_browser_workflow_verified":true,"verified_ci_run_url":"https://github.com/shi1720/DAISI/actions/runs/35691832262","verified_ci_revision":"1ba692e321f7453973cae2543df674450778eec5","local_source_archive_install_verified":true,"local_source_archive_verification":"Frozen dependency installation, frontend build, isolated local server, authenticated 225-meal proposal, five preserved sources, PDF export and synthetic plan cleanup.","local_source_archive_code_revision":"c279088","silent_demo_path":"output/video/hawkerbridge-demo-silent.mp4","silent_demo_execution_environment":"Local application in isolated GitHub Actions runner; not a recording of a hosted Databricks App.","silent_demo_capture_run_url":"https://github.com/shi1720/DAISI/actions/runs/35691366315","silent_demo_capture_note":"The recording test passed; that run also found expanded-banner contrast defects, which were fixed and verified by the later successful CI run. See output/video/provenance.json.","video_assembler_verified":true,"video_assembler_verification":"H.264 silent output and H.264/AAC output using a temporary test-silence input both verified at 175 seconds; local-execution footer visually inspected. No participant voiceover is claimed.","public_app_url":"https://hawkerbridge-sg.web.app","public_app_verification":"Hosted HTTP acceptance passed on hawkerbridge-api-00002-6x7: named and guest auth, secure sessions, owner isolation,225/450/450,all exports,CSRF/origin boundaries,concurrent edit409 and matching12/9/15 evidence. Saved account and225-meal plan survived rollout to hawkerbridge-api-00003-92d; test account removed. Real hosted browser journeys running separately.","databricks_publication_id":"69cbf18aae9c4f1883b629ab0de25843","databricks_input_mode":"live","databricks_cloud_scenarios":9,"source_fingerprint":"a3b84df2577a59a9d1cf6ccaf8cb45b47a0caffa4429122e1f409a29de274c4f","databricks_app_verification":"Actual OAuth health/session/evidence200, anonymous401,225/450/450 budget workflow; real Delta owner isolation and concurrent update conflict. See docs/databricks-verification.json. Browser render and second real workspace identity not yet tested.","public_api_revision":"hawkerbridge-api-00003-92d","hosted_smoke_report":"output/hosted-smoke.json","hosted_restart_report":"output/hosted-restart-smoke.json","public_retention_job":"hawkerbridge-retention","public_retention_schedule":"Hourly at minute15, Asia/Singapore"}. Unity Catalog governance and explicit lineage records are implemented. Do not claim unverified automatic column lineage. Publication uses staging plus a final pointer record, not cross-table ACID. Archived replay is explicitly labeled if used. Cloud mode fails closed rather than silently displaying local data. Free Edition limitations: https://docs.databricks.com/aws/en/getting-started/free-edition-limitations .</a:t>
             </a:r>
           </a:p>
         </p:txBody>
@@ -1055,7 +1055,7 @@
           <a:lstStyle xmlns:a="http://schemas.openxmlformats.org/drawingml/2006/main"/>
           <a:p xmlns:a="http://schemas.openxmlformats.org/drawingml/2006/main">
             <a:r>
-              <a:t>Prospective validation protocol: submission/whats-next.md, submission/buyer-interview-guide.md and docs/business-case.md. No stakeholder interview, actual pilot, commercial commitment or measured welfare outcome is claimed. At least three non-leading interviews and observation of an existing workflow should precede a funded engagement. Compare equal preparation tasks, record corrections, venue rejection, support hours and willingness to repeat a paid engagement. The small pilot cannot establish national causal impact. Platform prerequisite status: {"local_app_tested":true,"databricks_workspace_execution_verified":false,"databricks_app_url":null,"successful_pipeline_run_url":null,"mlflow_run_url":null,"public_or_unlisted_video_url":null,"note":"This records actual evidence, not intended architecture. Populate cloud links only after successful workspace execution."}. Newer compatible demographics and real operator capacity are prioritised inputs. Project owner: Shivam Gupta. Confirm eligibility and full team details separately; the deck does not imply IHL enrollment.</a:t>
+              <a:t>Prospective validation protocol: submission/whats-next.md, submission/buyer-interview-guide.md and docs/business-case.md. No stakeholder interview, actual pilot, commercial commitment or measured welfare outcome is claimed. At least three non-leading interviews and observation of an existing workflow should precede a funded engagement. Compare equal preparation tasks, record corrections, venue rejection, support hours and willingness to repeat a paid engagement. The small pilot cannot establish national causal impact. Platform prerequisite status: {"local_app_tested":true,"databricks_workspace_execution_verified":true,"databricks_app_url":"https://hawkerbridge-7474659582484876.aws.databricksapps.com","successful_pipeline_run_url":"https://dbc-6fea141d-04eb.cloud.databricks.com/jobs/929729986607018/runs/1046237288082887?o=7474659582484876","mlflow_run_url":"https://dbc-6fea141d-04eb.cloud.databricks.com/ml/experiments/2274018642838106/runs/6b80647b3eea44d5bf9af59c315eec66","public_or_unlisted_video_url":null,"note":"This records actual evidence, not intended architecture. Populate cloud links only after successful workspace execution.","local_browser_workflow_verified":true,"verified_ci_run_url":"https://github.com/shi1720/DAISI/actions/runs/35691832262","verified_ci_revision":"1ba692e321f7453973cae2543df674450778eec5","local_source_archive_install_verified":true,"local_source_archive_verification":"Frozen dependency installation, frontend build, isolated local server, authenticated 225-meal proposal, five preserved sources, PDF export and synthetic plan cleanup.","local_source_archive_code_revision":"c279088","silent_demo_path":"output/video/hawkerbridge-demo-silent.mp4","silent_demo_execution_environment":"Local application in isolated GitHub Actions runner; not a recording of a hosted Databricks App.","silent_demo_capture_run_url":"https://github.com/shi1720/DAISI/actions/runs/35691366315","silent_demo_capture_note":"The recording test passed; that run also found expanded-banner contrast defects, which were fixed and verified by the later successful CI run. See output/video/provenance.json.","video_assembler_verified":true,"video_assembler_verification":"H.264 silent output and H.264/AAC output using a temporary test-silence input both verified at 175 seconds; local-execution footer visually inspected. No participant voiceover is claimed.","public_app_url":"https://hawkerbridge-sg.web.app","public_app_verification":"Hosted HTTP acceptance passed on hawkerbridge-api-00002-6x7: named and guest auth, secure sessions, owner isolation,225/450/450,all exports,CSRF/origin boundaries,concurrent edit409 and matching12/9/15 evidence. Saved account and225-meal plan survived rollout to hawkerbridge-api-00003-92d; test account removed. Real hosted browser journeys running separately.","databricks_publication_id":"69cbf18aae9c4f1883b629ab0de25843","databricks_input_mode":"live","databricks_cloud_scenarios":9,"source_fingerprint":"a3b84df2577a59a9d1cf6ccaf8cb45b47a0caffa4429122e1f409a29de274c4f","databricks_app_verification":"Actual OAuth health/session/evidence200, anonymous401,225/450/450 budget workflow; real Delta owner isolation and concurrent update conflict. See docs/databricks-verification.json. Browser render and second real workspace identity not yet tested.","public_api_revision":"hawkerbridge-api-00003-92d","hosted_smoke_report":"output/hosted-smoke.json","hosted_restart_report":"output/hosted-restart-smoke.json","public_retention_job":"hawkerbridge-retention","public_retention_schedule":"Hourly at minute15, Asia/Singapore"}. Newer compatible demographics and real operator capacity are prioritised inputs. Project owner: Shivam Gupta. Confirm eligibility and full team details separately; the deck does not imply IHL enrollment.</a:t>
             </a:r>
           </a:p>
         </p:txBody>
@@ -1123,7 +1123,7 @@
   </p:cSld>
   <p:clrMap bg1="lt1" tx1="dk1" bg2="lt2" tx2="dk2" accent1="accent1" accent2="accent2" accent3="accent3" accent4="accent4" accent5="accent5" accent6="accent6" hlink="hlink" folHlink="folHlink"/>
   <p:sldLayoutIdLst>
-    <p:sldLayoutId xmlns:r="http://schemas.openxmlformats.org/officeDocument/2006/relationships" id="2147483649" r:id="R5f0cb6db25434686"/>
+    <p:sldLayoutId xmlns:r="http://schemas.openxmlformats.org/officeDocument/2006/relationships" id="2147483649" r:id="Re62d13c5226d4652"/>
   </p:sldLayoutIdLst>
   <p:txStyles>
     <p:titleStyle>
@@ -1980,7 +1980,7 @@
           <p:cNvPr id="6" name="">
             <a:extLst xmlns:a="http://schemas.openxmlformats.org/drawingml/2006/main">
               <a:ext uri="{FF2B5EF4-FFF2-40B4-BE49-F238E27FC236}">
-                <a16:creationId xmlns:a16="http://schemas.microsoft.com/office/drawing/2014/main" id="{D4172984-6FB8-4491-A83B-942ABDE8CE37}"/>
+                <a16:creationId xmlns:a16="http://schemas.microsoft.com/office/drawing/2014/main" id="{D044BE0B-1F67-469B-94C5-CF278360314C}"/>
               </a:ext>
             </a:extLst>
           </p:cNvPr>
@@ -2037,7 +2037,7 @@
           <p:cNvPr id="2" name="">
             <a:extLst xmlns:a="http://schemas.openxmlformats.org/drawingml/2006/main">
               <a:ext uri="{FF2B5EF4-FFF2-40B4-BE49-F238E27FC236}">
-                <a16:creationId xmlns:a16="http://schemas.microsoft.com/office/drawing/2014/main" id="{2018CEC2-ED51-4684-AA9D-6E18C47B0363}"/>
+                <a16:creationId xmlns:a16="http://schemas.microsoft.com/office/drawing/2014/main" id="{9AF4CF19-0392-408B-8605-2F7969EBA65C}"/>
               </a:ext>
             </a:extLst>
           </p:cNvPr>
@@ -2117,7 +2117,7 @@
           <p:cNvPr id="3" name="">
             <a:extLst xmlns:a="http://schemas.openxmlformats.org/drawingml/2006/main">
               <a:ext uri="{FF2B5EF4-FFF2-40B4-BE49-F238E27FC236}">
-                <a16:creationId xmlns:a16="http://schemas.microsoft.com/office/drawing/2014/main" id="{70C5B567-0138-414E-ACAB-E8B46079B83D}"/>
+                <a16:creationId xmlns:a16="http://schemas.microsoft.com/office/drawing/2014/main" id="{901469A1-825B-4B75-AD45-3A9ADF309EEB}"/>
               </a:ext>
             </a:extLst>
           </p:cNvPr>
@@ -2224,7 +2224,7 @@
           <p:nvPr/>
         </p:nvPicPr>
         <p:blipFill>
-          <a:blip xmlns:r="http://schemas.openxmlformats.org/officeDocument/2006/relationships" xmlns:a="http://schemas.openxmlformats.org/drawingml/2006/main" r:embed="R93181d49eb2448fb"/>
+          <a:blip xmlns:r="http://schemas.openxmlformats.org/officeDocument/2006/relationships" xmlns:a="http://schemas.openxmlformats.org/drawingml/2006/main" r:embed="Rb2421fd0bd674973"/>
           <a:srcRect xmlns:a="http://schemas.openxmlformats.org/drawingml/2006/main" l="23958" t="0" r="23958" b="0"/>
           <a:stretch xmlns:a="http://schemas.openxmlformats.org/drawingml/2006/main">
             <a:fillRect l="0" t="0" r="0" b="0"/>
@@ -2245,7 +2245,7 @@
           <p:cNvPr id="5" name="">
             <a:extLst xmlns:a="http://schemas.openxmlformats.org/drawingml/2006/main">
               <a:ext uri="{FF2B5EF4-FFF2-40B4-BE49-F238E27FC236}">
-                <a16:creationId xmlns:a16="http://schemas.microsoft.com/office/drawing/2014/main" id="{75C4845D-7081-47EB-8FD9-79DECB533117}"/>
+                <a16:creationId xmlns:a16="http://schemas.microsoft.com/office/drawing/2014/main" id="{ACDAE934-BC21-4208-8BC6-08F17C3E63D5}"/>
               </a:ext>
             </a:extLst>
           </p:cNvPr>
@@ -2323,7 +2323,7 @@
     </p:spTree>
     <p:extLst>
       <p:ext uri="{BB962C8B-B14F-4D97-AF65-F5344CB8AC3E}">
-        <p14:creationId xmlns:p14="http://schemas.microsoft.com/office/powerpoint/2010/main" val="230599566"/>
+        <p14:creationId xmlns:p14="http://schemas.microsoft.com/office/powerpoint/2010/main" val="1545716915"/>
       </p:ext>
     </p:extLst>
   </p:cSld>
@@ -2354,7 +2354,7 @@
           <p:cNvPr id="10" name="">
             <a:extLst xmlns:a="http://schemas.openxmlformats.org/drawingml/2006/main">
               <a:ext uri="{FF2B5EF4-FFF2-40B4-BE49-F238E27FC236}">
-                <a16:creationId xmlns:a16="http://schemas.microsoft.com/office/drawing/2014/main" id="{26167D93-42AA-4FB7-99FD-EAAA4F6E6639}"/>
+                <a16:creationId xmlns:a16="http://schemas.microsoft.com/office/drawing/2014/main" id="{8300C5A4-20A0-4D5A-AA2A-D13B4BEB3CAF}"/>
               </a:ext>
             </a:extLst>
           </p:cNvPr>
@@ -2411,7 +2411,7 @@
           <p:cNvPr id="2" name="">
             <a:extLst xmlns:a="http://schemas.openxmlformats.org/drawingml/2006/main">
               <a:ext uri="{FF2B5EF4-FFF2-40B4-BE49-F238E27FC236}">
-                <a16:creationId xmlns:a16="http://schemas.microsoft.com/office/drawing/2014/main" id="{EE7EC243-F2AC-4FA6-A926-E0AF066625DC}"/>
+                <a16:creationId xmlns:a16="http://schemas.microsoft.com/office/drawing/2014/main" id="{8FCF369D-936A-4179-9A12-50AA65CF13EA}"/>
               </a:ext>
             </a:extLst>
           </p:cNvPr>
@@ -2468,7 +2468,7 @@
           <p:cNvPr id="3" name="">
             <a:extLst xmlns:a="http://schemas.openxmlformats.org/drawingml/2006/main">
               <a:ext uri="{FF2B5EF4-FFF2-40B4-BE49-F238E27FC236}">
-                <a16:creationId xmlns:a16="http://schemas.microsoft.com/office/drawing/2014/main" id="{1C6A40A5-46F2-4953-AD77-7DB91923EBC3}"/>
+                <a16:creationId xmlns:a16="http://schemas.microsoft.com/office/drawing/2014/main" id="{6A8ED466-667B-4389-B912-379F468BF00C}"/>
               </a:ext>
             </a:extLst>
           </p:cNvPr>
@@ -2525,7 +2525,7 @@
           <p:cNvPr id="4" name="">
             <a:extLst xmlns:a="http://schemas.openxmlformats.org/drawingml/2006/main">
               <a:ext uri="{FF2B5EF4-FFF2-40B4-BE49-F238E27FC236}">
-                <a16:creationId xmlns:a16="http://schemas.microsoft.com/office/drawing/2014/main" id="{DF1085A6-4831-4C5A-B1B2-137D9A891235}"/>
+                <a16:creationId xmlns:a16="http://schemas.microsoft.com/office/drawing/2014/main" id="{3C9EAEBE-E70C-4B44-8FFB-86E8D523D536}"/>
               </a:ext>
             </a:extLst>
           </p:cNvPr>
@@ -2582,7 +2582,7 @@
           <p:cNvPr id="5" name="">
             <a:extLst xmlns:a="http://schemas.openxmlformats.org/drawingml/2006/main">
               <a:ext uri="{FF2B5EF4-FFF2-40B4-BE49-F238E27FC236}">
-                <a16:creationId xmlns:a16="http://schemas.microsoft.com/office/drawing/2014/main" id="{9A5CC76F-62AB-4340-9190-EFCE2DFD8CDE}"/>
+                <a16:creationId xmlns:a16="http://schemas.microsoft.com/office/drawing/2014/main" id="{4B492FBA-FBF7-44EB-B062-8A1BACAFE17F}"/>
               </a:ext>
             </a:extLst>
           </p:cNvPr>
@@ -2639,7 +2639,7 @@
           <p:cNvPr id="6" name="">
             <a:extLst xmlns:a="http://schemas.openxmlformats.org/drawingml/2006/main">
               <a:ext uri="{FF2B5EF4-FFF2-40B4-BE49-F238E27FC236}">
-                <a16:creationId xmlns:a16="http://schemas.microsoft.com/office/drawing/2014/main" id="{EABAE75C-2F70-4F0E-8D19-C39D92A71381}"/>
+                <a16:creationId xmlns:a16="http://schemas.microsoft.com/office/drawing/2014/main" id="{EA347AC7-CFF9-44D9-8613-0978209FDFB7}"/>
               </a:ext>
             </a:extLst>
           </p:cNvPr>
@@ -2696,7 +2696,7 @@
           <p:cNvPr id="7" name="">
             <a:extLst xmlns:a="http://schemas.openxmlformats.org/drawingml/2006/main">
               <a:ext uri="{FF2B5EF4-FFF2-40B4-BE49-F238E27FC236}">
-                <a16:creationId xmlns:a16="http://schemas.microsoft.com/office/drawing/2014/main" id="{37BAE26E-1968-4283-BF10-3FB0C6E9F328}"/>
+                <a16:creationId xmlns:a16="http://schemas.microsoft.com/office/drawing/2014/main" id="{AE1FD414-DDDE-4100-9AC8-17E60B12ECA1}"/>
               </a:ext>
             </a:extLst>
           </p:cNvPr>
@@ -2753,7 +2753,7 @@
           <p:cNvPr id="8" name="">
             <a:extLst xmlns:a="http://schemas.openxmlformats.org/drawingml/2006/main">
               <a:ext uri="{FF2B5EF4-FFF2-40B4-BE49-F238E27FC236}">
-                <a16:creationId xmlns:a16="http://schemas.microsoft.com/office/drawing/2014/main" id="{008C20DA-671F-4F2C-BF11-DDBD1C4B9209}"/>
+                <a16:creationId xmlns:a16="http://schemas.microsoft.com/office/drawing/2014/main" id="{BD580213-4DB5-4E6D-B5B6-C234F2604DC0}"/>
               </a:ext>
             </a:extLst>
           </p:cNvPr>
@@ -2833,7 +2833,7 @@
           <p:cNvPr id="9" name="">
             <a:extLst xmlns:a="http://schemas.openxmlformats.org/drawingml/2006/main">
               <a:ext uri="{FF2B5EF4-FFF2-40B4-BE49-F238E27FC236}">
-                <a16:creationId xmlns:a16="http://schemas.microsoft.com/office/drawing/2014/main" id="{5190274C-083E-414F-9907-8A8DC4D9D1E5}"/>
+                <a16:creationId xmlns:a16="http://schemas.microsoft.com/office/drawing/2014/main" id="{40C8D640-F40F-45C7-A508-1FAE6D13BFF6}"/>
               </a:ext>
             </a:extLst>
           </p:cNvPr>
@@ -2888,7 +2888,7 @@
     </p:spTree>
     <p:extLst>
       <p:ext uri="{BB962C8B-B14F-4D97-AF65-F5344CB8AC3E}">
-        <p14:creationId xmlns:p14="http://schemas.microsoft.com/office/powerpoint/2010/main" val="949542453"/>
+        <p14:creationId xmlns:p14="http://schemas.microsoft.com/office/powerpoint/2010/main" val="1504852263"/>
       </p:ext>
     </p:extLst>
   </p:cSld>
@@ -2919,7 +2919,7 @@
           <p:cNvPr id="9" name="">
             <a:extLst xmlns:a="http://schemas.openxmlformats.org/drawingml/2006/main">
               <a:ext uri="{FF2B5EF4-FFF2-40B4-BE49-F238E27FC236}">
-                <a16:creationId xmlns:a16="http://schemas.microsoft.com/office/drawing/2014/main" id="{49C4C617-77F9-41CE-9187-43DDCC77103E}"/>
+                <a16:creationId xmlns:a16="http://schemas.microsoft.com/office/drawing/2014/main" id="{3FC05E27-2F6B-4599-B8B2-0028751FD476}"/>
               </a:ext>
             </a:extLst>
           </p:cNvPr>
@@ -2976,7 +2976,7 @@
           <p:cNvPr id="2" name="">
             <a:extLst xmlns:a="http://schemas.openxmlformats.org/drawingml/2006/main">
               <a:ext uri="{FF2B5EF4-FFF2-40B4-BE49-F238E27FC236}">
-                <a16:creationId xmlns:a16="http://schemas.microsoft.com/office/drawing/2014/main" id="{34027477-7D68-4D30-8F20-5B6578674454}"/>
+                <a16:creationId xmlns:a16="http://schemas.microsoft.com/office/drawing/2014/main" id="{8E033F6D-4FFF-4A28-9EDE-E3B28F096718}"/>
               </a:ext>
             </a:extLst>
           </p:cNvPr>
@@ -3037,7 +3037,7 @@
           <p:nvPr/>
         </p:nvPicPr>
         <p:blipFill>
-          <a:blip xmlns:r="http://schemas.openxmlformats.org/officeDocument/2006/relationships" xmlns:a="http://schemas.openxmlformats.org/drawingml/2006/main" r:embed="R0d533816c07c4064"/>
+          <a:blip xmlns:r="http://schemas.openxmlformats.org/officeDocument/2006/relationships" xmlns:a="http://schemas.openxmlformats.org/drawingml/2006/main" r:embed="R18ea12faabf4467a"/>
           <a:stretch xmlns:a="http://schemas.openxmlformats.org/drawingml/2006/main"/>
         </p:blipFill>
         <p:spPr>
@@ -3055,7 +3055,7 @@
           <p:cNvPr id="4" name="">
             <a:extLst xmlns:a="http://schemas.openxmlformats.org/drawingml/2006/main">
               <a:ext uri="{FF2B5EF4-FFF2-40B4-BE49-F238E27FC236}">
-                <a16:creationId xmlns:a16="http://schemas.microsoft.com/office/drawing/2014/main" id="{3FC0C504-36F1-4C64-AB17-202B1F4A0C3A}"/>
+                <a16:creationId xmlns:a16="http://schemas.microsoft.com/office/drawing/2014/main" id="{8C63C8BE-5A20-4A32-B765-B62CE683BB3D}"/>
               </a:ext>
             </a:extLst>
           </p:cNvPr>
@@ -3112,7 +3112,7 @@
           <p:cNvPr id="5" name="">
             <a:extLst xmlns:a="http://schemas.openxmlformats.org/drawingml/2006/main">
               <a:ext uri="{FF2B5EF4-FFF2-40B4-BE49-F238E27FC236}">
-                <a16:creationId xmlns:a16="http://schemas.microsoft.com/office/drawing/2014/main" id="{159D08A9-87F2-471B-8F4B-D8196C660127}"/>
+                <a16:creationId xmlns:a16="http://schemas.microsoft.com/office/drawing/2014/main" id="{2CD13424-5889-41FB-BF13-A1614B1BEC73}"/>
               </a:ext>
             </a:extLst>
           </p:cNvPr>
@@ -3215,7 +3215,7 @@
           <p:cNvPr id="6" name="">
             <a:extLst xmlns:a="http://schemas.openxmlformats.org/drawingml/2006/main">
               <a:ext uri="{FF2B5EF4-FFF2-40B4-BE49-F238E27FC236}">
-                <a16:creationId xmlns:a16="http://schemas.microsoft.com/office/drawing/2014/main" id="{3C1A613F-8774-47A9-885D-F5E9E5C72A64}"/>
+                <a16:creationId xmlns:a16="http://schemas.microsoft.com/office/drawing/2014/main" id="{D8A3B873-6BF2-4800-AA94-607BC537FD85}"/>
               </a:ext>
             </a:extLst>
           </p:cNvPr>
@@ -3272,7 +3272,7 @@
           <p:cNvPr id="7" name="">
             <a:extLst xmlns:a="http://schemas.openxmlformats.org/drawingml/2006/main">
               <a:ext uri="{FF2B5EF4-FFF2-40B4-BE49-F238E27FC236}">
-                <a16:creationId xmlns:a16="http://schemas.microsoft.com/office/drawing/2014/main" id="{B599C818-CCBE-4FBD-9946-54963AD48D5A}"/>
+                <a16:creationId xmlns:a16="http://schemas.microsoft.com/office/drawing/2014/main" id="{0FDB026E-BF0D-4072-B219-FCA486AFFA6F}"/>
               </a:ext>
             </a:extLst>
           </p:cNvPr>
@@ -3375,7 +3375,7 @@
           <p:cNvPr id="8" name="">
             <a:extLst xmlns:a="http://schemas.openxmlformats.org/drawingml/2006/main">
               <a:ext uri="{FF2B5EF4-FFF2-40B4-BE49-F238E27FC236}">
-                <a16:creationId xmlns:a16="http://schemas.microsoft.com/office/drawing/2014/main" id="{6DE2789F-D721-49CE-B245-A13D01CCBB7B}"/>
+                <a16:creationId xmlns:a16="http://schemas.microsoft.com/office/drawing/2014/main" id="{74132815-34AA-41A8-91F5-FF23083BC729}"/>
               </a:ext>
             </a:extLst>
           </p:cNvPr>
@@ -3422,7 +3422,7 @@
                 <a:ea typeface="Helvetica Neue"/>
                 <a:cs typeface="Helvetica Neue"/>
               </a:rPr>
-              <a:t>Actual local application. Cleaning-date changes are hypothetical. Area exposure is a screening proxy.</a:t>
+              <a:t>Actual hosted application. Cleaning-date changes are hypothetical. Area exposure is a screening proxy.</a:t>
             </a:r>
           </a:p>
         </p:txBody>
@@ -3430,7 +3430,7 @@
     </p:spTree>
     <p:extLst>
       <p:ext uri="{BB962C8B-B14F-4D97-AF65-F5344CB8AC3E}">
-        <p14:creationId xmlns:p14="http://schemas.microsoft.com/office/powerpoint/2010/main" val="366348097"/>
+        <p14:creationId xmlns:p14="http://schemas.microsoft.com/office/powerpoint/2010/main" val="166633752"/>
       </p:ext>
     </p:extLst>
   </p:cSld>
@@ -3461,7 +3461,7 @@
           <p:cNvPr id="9" name="">
             <a:extLst xmlns:a="http://schemas.openxmlformats.org/drawingml/2006/main">
               <a:ext uri="{FF2B5EF4-FFF2-40B4-BE49-F238E27FC236}">
-                <a16:creationId xmlns:a16="http://schemas.microsoft.com/office/drawing/2014/main" id="{29ABCF9A-2346-4EA1-8082-668C337CB6BC}"/>
+                <a16:creationId xmlns:a16="http://schemas.microsoft.com/office/drawing/2014/main" id="{52F8AB3C-D4FC-4DB4-BFDE-B381903FC797}"/>
               </a:ext>
             </a:extLst>
           </p:cNvPr>
@@ -3518,7 +3518,7 @@
           <p:cNvPr id="2" name="">
             <a:extLst xmlns:a="http://schemas.openxmlformats.org/drawingml/2006/main">
               <a:ext uri="{FF2B5EF4-FFF2-40B4-BE49-F238E27FC236}">
-                <a16:creationId xmlns:a16="http://schemas.microsoft.com/office/drawing/2014/main" id="{12951C88-A765-4B9B-BE14-90CF3DD19FCF}"/>
+                <a16:creationId xmlns:a16="http://schemas.microsoft.com/office/drawing/2014/main" id="{A07E1B2D-3264-4A33-9296-5C17F66EF7EA}"/>
               </a:ext>
             </a:extLst>
           </p:cNvPr>
@@ -4042,7 +4042,7 @@
           <p:cNvPr id="4" name="">
             <a:extLst xmlns:a="http://schemas.openxmlformats.org/drawingml/2006/main">
               <a:ext uri="{FF2B5EF4-FFF2-40B4-BE49-F238E27FC236}">
-                <a16:creationId xmlns:a16="http://schemas.microsoft.com/office/drawing/2014/main" id="{05565357-BF7D-4F41-89D4-27C293259E6B}"/>
+                <a16:creationId xmlns:a16="http://schemas.microsoft.com/office/drawing/2014/main" id="{B5EE0BD8-C317-4A5B-9DC3-E5360A0B8CD1}"/>
               </a:ext>
             </a:extLst>
           </p:cNvPr>
@@ -4099,7 +4099,7 @@
           <p:cNvPr id="5" name="">
             <a:extLst xmlns:a="http://schemas.openxmlformats.org/drawingml/2006/main">
               <a:ext uri="{FF2B5EF4-FFF2-40B4-BE49-F238E27FC236}">
-                <a16:creationId xmlns:a16="http://schemas.microsoft.com/office/drawing/2014/main" id="{3FF46C1F-2D4E-4DC2-A646-96FE4109FEEF}"/>
+                <a16:creationId xmlns:a16="http://schemas.microsoft.com/office/drawing/2014/main" id="{90330787-8B01-4F5B-AB80-ED2C73782A21}"/>
               </a:ext>
             </a:extLst>
           </p:cNvPr>
@@ -4156,7 +4156,7 @@
           <p:cNvPr id="6" name="">
             <a:extLst xmlns:a="http://schemas.openxmlformats.org/drawingml/2006/main">
               <a:ext uri="{FF2B5EF4-FFF2-40B4-BE49-F238E27FC236}">
-                <a16:creationId xmlns:a16="http://schemas.microsoft.com/office/drawing/2014/main" id="{05FF51ED-DC13-4A81-A125-66B53EA91CB5}"/>
+                <a16:creationId xmlns:a16="http://schemas.microsoft.com/office/drawing/2014/main" id="{0C6DB4A3-C70F-40D5-82F2-5551C0882D15}"/>
               </a:ext>
             </a:extLst>
           </p:cNvPr>
@@ -4213,7 +4213,7 @@
           <p:cNvPr id="7" name="">
             <a:extLst xmlns:a="http://schemas.openxmlformats.org/drawingml/2006/main">
               <a:ext uri="{FF2B5EF4-FFF2-40B4-BE49-F238E27FC236}">
-                <a16:creationId xmlns:a16="http://schemas.microsoft.com/office/drawing/2014/main" id="{CBFD1DD5-7568-4997-8ED4-CA6FACC223E9}"/>
+                <a16:creationId xmlns:a16="http://schemas.microsoft.com/office/drawing/2014/main" id="{37BD8379-D2EA-4137-8E13-42E7FE2ED246}"/>
               </a:ext>
             </a:extLst>
           </p:cNvPr>
@@ -4270,7 +4270,7 @@
           <p:cNvPr id="8" name="">
             <a:extLst xmlns:a="http://schemas.openxmlformats.org/drawingml/2006/main">
               <a:ext uri="{FF2B5EF4-FFF2-40B4-BE49-F238E27FC236}">
-                <a16:creationId xmlns:a16="http://schemas.microsoft.com/office/drawing/2014/main" id="{FBF7D2A8-A6BC-4284-8727-018BBFD3287A}"/>
+                <a16:creationId xmlns:a16="http://schemas.microsoft.com/office/drawing/2014/main" id="{30D8D772-740B-4463-8C05-5226BD90718A}"/>
               </a:ext>
             </a:extLst>
           </p:cNvPr>
@@ -4325,7 +4325,7 @@
     </p:spTree>
     <p:extLst>
       <p:ext uri="{BB962C8B-B14F-4D97-AF65-F5344CB8AC3E}">
-        <p14:creationId xmlns:p14="http://schemas.microsoft.com/office/powerpoint/2010/main" val="2063714219"/>
+        <p14:creationId xmlns:p14="http://schemas.microsoft.com/office/powerpoint/2010/main" val="30881187"/>
       </p:ext>
     </p:extLst>
   </p:cSld>
@@ -4356,7 +4356,7 @@
           <p:cNvPr id="7" name="">
             <a:extLst xmlns:a="http://schemas.openxmlformats.org/drawingml/2006/main">
               <a:ext uri="{FF2B5EF4-FFF2-40B4-BE49-F238E27FC236}">
-                <a16:creationId xmlns:a16="http://schemas.microsoft.com/office/drawing/2014/main" id="{1DE396B6-C053-43EC-97E0-5AA8C09BE8F1}"/>
+                <a16:creationId xmlns:a16="http://schemas.microsoft.com/office/drawing/2014/main" id="{2E0A572A-0AB7-46C5-AA8C-269A8ABBAC12}"/>
               </a:ext>
             </a:extLst>
           </p:cNvPr>
@@ -4413,7 +4413,7 @@
           <p:cNvPr id="2" name="">
             <a:extLst xmlns:a="http://schemas.openxmlformats.org/drawingml/2006/main">
               <a:ext uri="{FF2B5EF4-FFF2-40B4-BE49-F238E27FC236}">
-                <a16:creationId xmlns:a16="http://schemas.microsoft.com/office/drawing/2014/main" id="{7BA9A45F-FE23-4CDF-8570-E432369E6662}"/>
+                <a16:creationId xmlns:a16="http://schemas.microsoft.com/office/drawing/2014/main" id="{5B21F86A-8929-4D73-8C61-F6A312FB7D17}"/>
               </a:ext>
             </a:extLst>
           </p:cNvPr>
@@ -4869,7 +4869,7 @@
                           <a:ea typeface="Helvetica Neue"/>
                           <a:cs typeface="Helvetica Neue"/>
                         </a:rPr>
-                        <a:t>Application</a:t>
+                        <a:t>Delivery</a:t>
                       </a:r>
                     </a:p>
                   </a:txBody>
@@ -4893,7 +4893,7 @@
                           <a:ea typeface="Helvetica Neue"/>
                           <a:cs typeface="Helvetica Neue"/>
                         </a:rPr>
-                        <a:t>Databricks App + SQL warehouse</a:t>
+                        <a:t>Databricks App + Firebase site</a:t>
                       </a:r>
                     </a:p>
                   </a:txBody>
@@ -4917,7 +4917,7 @@
                           <a:ea typeface="Helvetica Neue"/>
                           <a:cs typeface="Helvetica Neue"/>
                         </a:rPr>
-                        <a:t>Platform sign-in and saved proposals</a:t>
+                        <a:t>Same publication; private proposals</a:t>
                       </a:r>
                     </a:p>
                   </a:txBody>
@@ -4937,7 +4937,7 @@
           <p:cNvPr id="4" name="">
             <a:extLst xmlns:a="http://schemas.openxmlformats.org/drawingml/2006/main">
               <a:ext uri="{FF2B5EF4-FFF2-40B4-BE49-F238E27FC236}">
-                <a16:creationId xmlns:a16="http://schemas.microsoft.com/office/drawing/2014/main" id="{84A7C47A-B8DA-4736-83D1-671438E2D20C}"/>
+                <a16:creationId xmlns:a16="http://schemas.microsoft.com/office/drawing/2014/main" id="{8557BE8C-C9FC-43B7-B5A4-DD213BAF0FD1}"/>
               </a:ext>
             </a:extLst>
           </p:cNvPr>
@@ -4968,7 +4968,7 @@
             <a:pPr>
               <a:defRPr sz="2400" b="1">
                 <a:solidFill>
-                  <a:srgbClr val="C94C30"/>
+                  <a:srgbClr val="173D35"/>
                 </a:solidFill>
                 <a:latin typeface="Helvetica Neue"/>
                 <a:ea typeface="Helvetica Neue"/>
@@ -4978,13 +4978,13 @@
             <a:r>
               <a:rPr sz="2400" b="1">
                 <a:solidFill>
-                  <a:srgbClr val="C94C30"/>
-                </a:solidFill>
-                <a:latin typeface="Helvetica Neue"/>
-                <a:ea typeface="Helvetica Neue"/>
-                <a:cs typeface="Helvetica Neue"/>
-              </a:rPr>
-              <a:t>Workspace execution pending</a:t>
+                  <a:srgbClr val="173D35"/>
+                </a:solidFill>
+                <a:latin typeface="Helvetica Neue"/>
+                <a:ea typeface="Helvetica Neue"/>
+                <a:cs typeface="Helvetica Neue"/>
+              </a:rPr>
+              <a:t>Workspace execution verified</a:t>
             </a:r>
           </a:p>
         </p:txBody>
@@ -4994,7 +4994,7 @@
           <p:cNvPr id="5" name="">
             <a:extLst xmlns:a="http://schemas.openxmlformats.org/drawingml/2006/main">
               <a:ext uri="{FF2B5EF4-FFF2-40B4-BE49-F238E27FC236}">
-                <a16:creationId xmlns:a16="http://schemas.microsoft.com/office/drawing/2014/main" id="{427C6C6A-6B98-45B7-8E7B-BB1A2A88F214}"/>
+                <a16:creationId xmlns:a16="http://schemas.microsoft.com/office/drawing/2014/main" id="{0730D696-838F-4FC9-836E-E53EF1F83EC8}"/>
               </a:ext>
             </a:extLst>
           </p:cNvPr>
@@ -5041,7 +5041,7 @@
                 <a:ea typeface="Helvetica Neue"/>
                 <a:cs typeface="Helvetica Neue"/>
               </a:rPr>
-              <a:t>Local execution verified. Cloud run evidence remains the next gate.</a:t>
+              <a:t>12 quality gates. 9 cloud scenarios. Published data powers the public app.</a:t>
             </a:r>
           </a:p>
         </p:txBody>
@@ -5051,7 +5051,7 @@
           <p:cNvPr id="6" name="">
             <a:extLst xmlns:a="http://schemas.openxmlformats.org/drawingml/2006/main">
               <a:ext uri="{FF2B5EF4-FFF2-40B4-BE49-F238E27FC236}">
-                <a16:creationId xmlns:a16="http://schemas.microsoft.com/office/drawing/2014/main" id="{E1E936AB-EF24-4B89-B75D-23D8B6758996}"/>
+                <a16:creationId xmlns:a16="http://schemas.microsoft.com/office/drawing/2014/main" id="{51A65F3A-977A-4493-9584-4CAFEF6DF0EE}"/>
               </a:ext>
             </a:extLst>
           </p:cNvPr>
@@ -5106,7 +5106,7 @@
     </p:spTree>
     <p:extLst>
       <p:ext uri="{BB962C8B-B14F-4D97-AF65-F5344CB8AC3E}">
-        <p14:creationId xmlns:p14="http://schemas.microsoft.com/office/powerpoint/2010/main" val="1577642337"/>
+        <p14:creationId xmlns:p14="http://schemas.microsoft.com/office/powerpoint/2010/main" val="430130211"/>
       </p:ext>
     </p:extLst>
   </p:cSld>
@@ -5137,7 +5137,7 @@
           <p:cNvPr id="10" name="">
             <a:extLst xmlns:a="http://schemas.openxmlformats.org/drawingml/2006/main">
               <a:ext uri="{FF2B5EF4-FFF2-40B4-BE49-F238E27FC236}">
-                <a16:creationId xmlns:a16="http://schemas.microsoft.com/office/drawing/2014/main" id="{92522CE5-4570-4CD1-A8C2-6EAAC1F20659}"/>
+                <a16:creationId xmlns:a16="http://schemas.microsoft.com/office/drawing/2014/main" id="{92690709-4233-413C-AD12-372709A647E7}"/>
               </a:ext>
             </a:extLst>
           </p:cNvPr>
@@ -5194,7 +5194,7 @@
           <p:cNvPr id="2" name="">
             <a:extLst xmlns:a="http://schemas.openxmlformats.org/drawingml/2006/main">
               <a:ext uri="{FF2B5EF4-FFF2-40B4-BE49-F238E27FC236}">
-                <a16:creationId xmlns:a16="http://schemas.microsoft.com/office/drawing/2014/main" id="{49D42DB1-E023-4F1C-8459-BC329BE4344F}"/>
+                <a16:creationId xmlns:a16="http://schemas.microsoft.com/office/drawing/2014/main" id="{0FA1665D-2F6F-4AAB-A83D-EEA5FB912FB9}"/>
               </a:ext>
             </a:extLst>
           </p:cNvPr>
@@ -5251,7 +5251,7 @@
           <p:cNvPr id="3" name="">
             <a:extLst xmlns:a="http://schemas.openxmlformats.org/drawingml/2006/main">
               <a:ext uri="{FF2B5EF4-FFF2-40B4-BE49-F238E27FC236}">
-                <a16:creationId xmlns:a16="http://schemas.microsoft.com/office/drawing/2014/main" id="{1D21F369-BBF3-48EB-B144-3C4D43423683}"/>
+                <a16:creationId xmlns:a16="http://schemas.microsoft.com/office/drawing/2014/main" id="{BC08DCDC-E3D9-4E0A-97FB-C4873C987195}"/>
               </a:ext>
             </a:extLst>
           </p:cNvPr>
@@ -5315,7 +5315,7 @@
         </p:xfrm>
         <a:graphic xmlns:a="http://schemas.openxmlformats.org/drawingml/2006/main">
           <a:graphicData uri="http://schemas.openxmlformats.org/drawingml/2006/chart">
-            <c:chart xmlns:r="http://schemas.openxmlformats.org/officeDocument/2006/relationships" xmlns:c="http://schemas.openxmlformats.org/drawingml/2006/chart" r:id="Rdb26119152da43ee"/>
+            <c:chart xmlns:r="http://schemas.openxmlformats.org/officeDocument/2006/relationships" xmlns:c="http://schemas.openxmlformats.org/drawingml/2006/chart" r:id="R3d614503e68847fa"/>
           </a:graphicData>
         </a:graphic>
       </p:graphicFrame>
@@ -5324,7 +5324,7 @@
           <p:cNvPr id="5" name="">
             <a:extLst xmlns:a="http://schemas.openxmlformats.org/drawingml/2006/main">
               <a:ext uri="{FF2B5EF4-FFF2-40B4-BE49-F238E27FC236}">
-                <a16:creationId xmlns:a16="http://schemas.microsoft.com/office/drawing/2014/main" id="{C3261FF6-B222-464E-8C62-3D8D06795DDB}"/>
+                <a16:creationId xmlns:a16="http://schemas.microsoft.com/office/drawing/2014/main" id="{7C0DEA47-AB77-4BC0-B628-30CBF5AF9742}"/>
               </a:ext>
             </a:extLst>
           </p:cNvPr>
@@ -5381,7 +5381,7 @@
           <p:cNvPr id="6" name="">
             <a:extLst xmlns:a="http://schemas.openxmlformats.org/drawingml/2006/main">
               <a:ext uri="{FF2B5EF4-FFF2-40B4-BE49-F238E27FC236}">
-                <a16:creationId xmlns:a16="http://schemas.microsoft.com/office/drawing/2014/main" id="{BE7CB778-24E4-4B48-A608-29FE05673EB2}"/>
+                <a16:creationId xmlns:a16="http://schemas.microsoft.com/office/drawing/2014/main" id="{00AAA958-D216-4FEE-B608-670DB8D2428C}"/>
               </a:ext>
             </a:extLst>
           </p:cNvPr>
@@ -5461,7 +5461,7 @@
           <p:cNvPr id="7" name="">
             <a:extLst xmlns:a="http://schemas.openxmlformats.org/drawingml/2006/main">
               <a:ext uri="{FF2B5EF4-FFF2-40B4-BE49-F238E27FC236}">
-                <a16:creationId xmlns:a16="http://schemas.microsoft.com/office/drawing/2014/main" id="{37EF52D3-6FBB-40D1-A22A-3EDC8EFF832F}"/>
+                <a16:creationId xmlns:a16="http://schemas.microsoft.com/office/drawing/2014/main" id="{112A2F01-3BEB-4CF0-9297-795CA95F7574}"/>
               </a:ext>
             </a:extLst>
           </p:cNvPr>
@@ -5564,7 +5564,7 @@
           <p:cNvPr id="8" name="">
             <a:extLst xmlns:a="http://schemas.openxmlformats.org/drawingml/2006/main">
               <a:ext uri="{FF2B5EF4-FFF2-40B4-BE49-F238E27FC236}">
-                <a16:creationId xmlns:a16="http://schemas.microsoft.com/office/drawing/2014/main" id="{874799C4-A207-48F9-B8BC-3C1469F9460C}"/>
+                <a16:creationId xmlns:a16="http://schemas.microsoft.com/office/drawing/2014/main" id="{F4F5748D-5E81-4469-AD26-E769997DC4EB}"/>
               </a:ext>
             </a:extLst>
           </p:cNvPr>
@@ -5621,7 +5621,7 @@
           <p:cNvPr id="9" name="">
             <a:extLst xmlns:a="http://schemas.openxmlformats.org/drawingml/2006/main">
               <a:ext uri="{FF2B5EF4-FFF2-40B4-BE49-F238E27FC236}">
-                <a16:creationId xmlns:a16="http://schemas.microsoft.com/office/drawing/2014/main" id="{DC1B2F0E-196F-4B97-9922-06C20DC49395}"/>
+                <a16:creationId xmlns:a16="http://schemas.microsoft.com/office/drawing/2014/main" id="{66B92589-E950-4C2F-9388-C714164737F5}"/>
               </a:ext>
             </a:extLst>
           </p:cNvPr>
@@ -5676,7 +5676,7 @@
     </p:spTree>
     <p:extLst>
       <p:ext uri="{BB962C8B-B14F-4D97-AF65-F5344CB8AC3E}">
-        <p14:creationId xmlns:p14="http://schemas.microsoft.com/office/powerpoint/2010/main" val="444170366"/>
+        <p14:creationId xmlns:p14="http://schemas.microsoft.com/office/powerpoint/2010/main" val="392514333"/>
       </p:ext>
     </p:extLst>
   </p:cSld>
@@ -5707,7 +5707,7 @@
           <p:cNvPr id="9" name="">
             <a:extLst xmlns:a="http://schemas.openxmlformats.org/drawingml/2006/main">
               <a:ext uri="{FF2B5EF4-FFF2-40B4-BE49-F238E27FC236}">
-                <a16:creationId xmlns:a16="http://schemas.microsoft.com/office/drawing/2014/main" id="{AF59CBC9-AFCA-4CD2-9284-4EC3AF055999}"/>
+                <a16:creationId xmlns:a16="http://schemas.microsoft.com/office/drawing/2014/main" id="{D0D5C6F4-AB82-4056-9105-E421284551A0}"/>
               </a:ext>
             </a:extLst>
           </p:cNvPr>
@@ -5764,7 +5764,7 @@
           <p:cNvPr id="2" name="">
             <a:extLst xmlns:a="http://schemas.openxmlformats.org/drawingml/2006/main">
               <a:ext uri="{FF2B5EF4-FFF2-40B4-BE49-F238E27FC236}">
-                <a16:creationId xmlns:a16="http://schemas.microsoft.com/office/drawing/2014/main" id="{CF8DA1B8-F71A-4244-B864-4E7AF8F70699}"/>
+                <a16:creationId xmlns:a16="http://schemas.microsoft.com/office/drawing/2014/main" id="{5019849C-A96E-4C5B-87DB-2D268FC7F572}"/>
               </a:ext>
             </a:extLst>
           </p:cNvPr>
@@ -5825,7 +5825,7 @@
           <p:nvPr/>
         </p:nvPicPr>
         <p:blipFill>
-          <a:blip xmlns:r="http://schemas.openxmlformats.org/officeDocument/2006/relationships" xmlns:a="http://schemas.openxmlformats.org/drawingml/2006/main" r:embed="R40346475b00a4d9b"/>
+          <a:blip xmlns:r="http://schemas.openxmlformats.org/officeDocument/2006/relationships" xmlns:a="http://schemas.openxmlformats.org/drawingml/2006/main" r:embed="Rf2d260e8cf444d82"/>
           <a:stretch xmlns:a="http://schemas.openxmlformats.org/drawingml/2006/main"/>
         </p:blipFill>
         <p:spPr>
@@ -5843,7 +5843,7 @@
           <p:cNvPr id="4" name="">
             <a:extLst xmlns:a="http://schemas.openxmlformats.org/drawingml/2006/main">
               <a:ext uri="{FF2B5EF4-FFF2-40B4-BE49-F238E27FC236}">
-                <a16:creationId xmlns:a16="http://schemas.microsoft.com/office/drawing/2014/main" id="{6B425C03-6CA1-4CAB-B514-4F5AE3B121C0}"/>
+                <a16:creationId xmlns:a16="http://schemas.microsoft.com/office/drawing/2014/main" id="{0BD4E167-B824-4145-A92F-4471BA19FADE}"/>
               </a:ext>
             </a:extLst>
           </p:cNvPr>
@@ -5900,7 +5900,7 @@
           <p:cNvPr id="5" name="">
             <a:extLst xmlns:a="http://schemas.openxmlformats.org/drawingml/2006/main">
               <a:ext uri="{FF2B5EF4-FFF2-40B4-BE49-F238E27FC236}">
-                <a16:creationId xmlns:a16="http://schemas.microsoft.com/office/drawing/2014/main" id="{BEB9B0DD-87F2-4970-84CC-E5CEC6B32A54}"/>
+                <a16:creationId xmlns:a16="http://schemas.microsoft.com/office/drawing/2014/main" id="{98D65793-10D8-4234-A024-83DA3B74DDB0}"/>
               </a:ext>
             </a:extLst>
           </p:cNvPr>
@@ -5980,7 +5980,7 @@
           <p:cNvPr id="6" name="">
             <a:extLst xmlns:a="http://schemas.openxmlformats.org/drawingml/2006/main">
               <a:ext uri="{FF2B5EF4-FFF2-40B4-BE49-F238E27FC236}">
-                <a16:creationId xmlns:a16="http://schemas.microsoft.com/office/drawing/2014/main" id="{E0B54E39-E1FF-4C3D-89C9-8F7998E4BAC4}"/>
+                <a16:creationId xmlns:a16="http://schemas.microsoft.com/office/drawing/2014/main" id="{BD8C0F6F-0E31-4A08-915E-680FE618A9CD}"/>
               </a:ext>
             </a:extLst>
           </p:cNvPr>
@@ -6060,7 +6060,7 @@
           <p:cNvPr id="7" name="">
             <a:extLst xmlns:a="http://schemas.openxmlformats.org/drawingml/2006/main">
               <a:ext uri="{FF2B5EF4-FFF2-40B4-BE49-F238E27FC236}">
-                <a16:creationId xmlns:a16="http://schemas.microsoft.com/office/drawing/2014/main" id="{1E45857B-E419-407A-9F6C-CBD3A3914126}"/>
+                <a16:creationId xmlns:a16="http://schemas.microsoft.com/office/drawing/2014/main" id="{8C6F12A8-E2FE-4EE3-8E93-EEB49E1D20EB}"/>
               </a:ext>
             </a:extLst>
           </p:cNvPr>
@@ -6140,7 +6140,7 @@
           <p:cNvPr id="8" name="">
             <a:extLst xmlns:a="http://schemas.openxmlformats.org/drawingml/2006/main">
               <a:ext uri="{FF2B5EF4-FFF2-40B4-BE49-F238E27FC236}">
-                <a16:creationId xmlns:a16="http://schemas.microsoft.com/office/drawing/2014/main" id="{F9D90F1F-9BCC-4680-B642-4FF1C052D151}"/>
+                <a16:creationId xmlns:a16="http://schemas.microsoft.com/office/drawing/2014/main" id="{EB772861-DA9D-44E5-ACA0-2B1616190BC6}"/>
               </a:ext>
             </a:extLst>
           </p:cNvPr>
@@ -6195,7 +6195,7 @@
     </p:spTree>
     <p:extLst>
       <p:ext uri="{BB962C8B-B14F-4D97-AF65-F5344CB8AC3E}">
-        <p14:creationId xmlns:p14="http://schemas.microsoft.com/office/powerpoint/2010/main" val="321434030"/>
+        <p14:creationId xmlns:p14="http://schemas.microsoft.com/office/powerpoint/2010/main" val="2022684139"/>
       </p:ext>
     </p:extLst>
   </p:cSld>
@@ -6226,7 +6226,7 @@
           <p:cNvPr id="12" name="">
             <a:extLst xmlns:a="http://schemas.openxmlformats.org/drawingml/2006/main">
               <a:ext uri="{FF2B5EF4-FFF2-40B4-BE49-F238E27FC236}">
-                <a16:creationId xmlns:a16="http://schemas.microsoft.com/office/drawing/2014/main" id="{2E2198B9-D8D6-4F70-B90E-D08DC75B5AC0}"/>
+                <a16:creationId xmlns:a16="http://schemas.microsoft.com/office/drawing/2014/main" id="{A5D3864D-1F1F-417F-8A7E-9D881DD4B831}"/>
               </a:ext>
             </a:extLst>
           </p:cNvPr>
@@ -6283,7 +6283,7 @@
           <p:cNvPr id="2" name="">
             <a:extLst xmlns:a="http://schemas.openxmlformats.org/drawingml/2006/main">
               <a:ext uri="{FF2B5EF4-FFF2-40B4-BE49-F238E27FC236}">
-                <a16:creationId xmlns:a16="http://schemas.microsoft.com/office/drawing/2014/main" id="{BBEB27B8-60B0-4F70-90E2-5D76CAE2B85C}"/>
+                <a16:creationId xmlns:a16="http://schemas.microsoft.com/office/drawing/2014/main" id="{6B2A91AD-F090-4EFD-8509-27A804126115}"/>
               </a:ext>
             </a:extLst>
           </p:cNvPr>
@@ -6340,7 +6340,7 @@
           <p:cNvPr id="3" name="">
             <a:extLst xmlns:a="http://schemas.openxmlformats.org/drawingml/2006/main">
               <a:ext uri="{FF2B5EF4-FFF2-40B4-BE49-F238E27FC236}">
-                <a16:creationId xmlns:a16="http://schemas.microsoft.com/office/drawing/2014/main" id="{21B2E020-8B57-431D-9268-25564837357F}"/>
+                <a16:creationId xmlns:a16="http://schemas.microsoft.com/office/drawing/2014/main" id="{C7FB6E67-72ED-48C8-A985-6373E91E8E94}"/>
               </a:ext>
             </a:extLst>
           </p:cNvPr>
@@ -6397,7 +6397,7 @@
           <p:cNvPr id="4" name="">
             <a:extLst xmlns:a="http://schemas.openxmlformats.org/drawingml/2006/main">
               <a:ext uri="{FF2B5EF4-FFF2-40B4-BE49-F238E27FC236}">
-                <a16:creationId xmlns:a16="http://schemas.microsoft.com/office/drawing/2014/main" id="{1DDE230E-B509-4D98-BA83-B3D97E4AA1F9}"/>
+                <a16:creationId xmlns:a16="http://schemas.microsoft.com/office/drawing/2014/main" id="{31211F71-BEE2-4611-BF13-2ABE1ED99782}"/>
               </a:ext>
             </a:extLst>
           </p:cNvPr>
@@ -6477,7 +6477,7 @@
           <p:cNvPr id="5" name="">
             <a:extLst xmlns:a="http://schemas.openxmlformats.org/drawingml/2006/main">
               <a:ext uri="{FF2B5EF4-FFF2-40B4-BE49-F238E27FC236}">
-                <a16:creationId xmlns:a16="http://schemas.microsoft.com/office/drawing/2014/main" id="{9808568D-88A1-4A50-9B65-75AC2E743D58}"/>
+                <a16:creationId xmlns:a16="http://schemas.microsoft.com/office/drawing/2014/main" id="{802AF2A9-C443-4542-BAB3-E02DCBB13746}"/>
               </a:ext>
             </a:extLst>
           </p:cNvPr>
@@ -6557,7 +6557,7 @@
           <p:cNvPr id="6" name="">
             <a:extLst xmlns:a="http://schemas.openxmlformats.org/drawingml/2006/main">
               <a:ext uri="{FF2B5EF4-FFF2-40B4-BE49-F238E27FC236}">
-                <a16:creationId xmlns:a16="http://schemas.microsoft.com/office/drawing/2014/main" id="{20FE1F88-E79E-4E59-A8CF-471B46F65E16}"/>
+                <a16:creationId xmlns:a16="http://schemas.microsoft.com/office/drawing/2014/main" id="{043C3A91-E671-4492-A169-2DA6EA018A93}"/>
               </a:ext>
             </a:extLst>
           </p:cNvPr>
@@ -6614,7 +6614,7 @@
           <p:cNvPr id="7" name="">
             <a:extLst xmlns:a="http://schemas.openxmlformats.org/drawingml/2006/main">
               <a:ext uri="{FF2B5EF4-FFF2-40B4-BE49-F238E27FC236}">
-                <a16:creationId xmlns:a16="http://schemas.microsoft.com/office/drawing/2014/main" id="{E7AB3448-BACA-4FB5-8F1D-CEC91073152C}"/>
+                <a16:creationId xmlns:a16="http://schemas.microsoft.com/office/drawing/2014/main" id="{2B74F353-50A7-4714-85EE-8067EB03A9A8}"/>
               </a:ext>
             </a:extLst>
           </p:cNvPr>
@@ -6671,7 +6671,7 @@
           <p:cNvPr id="8" name="">
             <a:extLst xmlns:a="http://schemas.openxmlformats.org/drawingml/2006/main">
               <a:ext uri="{FF2B5EF4-FFF2-40B4-BE49-F238E27FC236}">
-                <a16:creationId xmlns:a16="http://schemas.microsoft.com/office/drawing/2014/main" id="{2D7F2736-1CE1-462C-8008-762F5C634CFA}"/>
+                <a16:creationId xmlns:a16="http://schemas.microsoft.com/office/drawing/2014/main" id="{E4D7CAAF-3AFE-4E26-9C8A-84D61778F4B9}"/>
               </a:ext>
             </a:extLst>
           </p:cNvPr>
@@ -6728,7 +6728,7 @@
           <p:cNvPr id="9" name="">
             <a:extLst xmlns:a="http://schemas.openxmlformats.org/drawingml/2006/main">
               <a:ext uri="{FF2B5EF4-FFF2-40B4-BE49-F238E27FC236}">
-                <a16:creationId xmlns:a16="http://schemas.microsoft.com/office/drawing/2014/main" id="{DA4579BA-BBF1-4A0E-B48F-78D5BA6E2B2A}"/>
+                <a16:creationId xmlns:a16="http://schemas.microsoft.com/office/drawing/2014/main" id="{A7BAFE05-1929-4F84-89CA-5A673CAC76E7}"/>
               </a:ext>
             </a:extLst>
           </p:cNvPr>
@@ -6808,7 +6808,7 @@
           <p:cNvPr id="10" name="">
             <a:extLst xmlns:a="http://schemas.openxmlformats.org/drawingml/2006/main">
               <a:ext uri="{FF2B5EF4-FFF2-40B4-BE49-F238E27FC236}">
-                <a16:creationId xmlns:a16="http://schemas.microsoft.com/office/drawing/2014/main" id="{BEC64649-EAA6-4FFD-898A-789823C8DFFC}"/>
+                <a16:creationId xmlns:a16="http://schemas.microsoft.com/office/drawing/2014/main" id="{B294D0CE-79E2-4349-81FC-551874B9FC35}"/>
               </a:ext>
             </a:extLst>
           </p:cNvPr>
@@ -6888,7 +6888,7 @@
           <p:cNvPr id="11" name="">
             <a:extLst xmlns:a="http://schemas.openxmlformats.org/drawingml/2006/main">
               <a:ext uri="{FF2B5EF4-FFF2-40B4-BE49-F238E27FC236}">
-                <a16:creationId xmlns:a16="http://schemas.microsoft.com/office/drawing/2014/main" id="{2C272B3E-C05B-4C16-9BA5-B630B8D5DA1E}"/>
+                <a16:creationId xmlns:a16="http://schemas.microsoft.com/office/drawing/2014/main" id="{B3C93D02-D0AA-4D69-9978-B107D1A7D9F2}"/>
               </a:ext>
             </a:extLst>
           </p:cNvPr>
@@ -6943,7 +6943,7 @@
     </p:spTree>
     <p:extLst>
       <p:ext uri="{BB962C8B-B14F-4D97-AF65-F5344CB8AC3E}">
-        <p14:creationId xmlns:p14="http://schemas.microsoft.com/office/powerpoint/2010/main" val="2055076581"/>
+        <p14:creationId xmlns:p14="http://schemas.microsoft.com/office/powerpoint/2010/main" val="160543436"/>
       </p:ext>
     </p:extLst>
   </p:cSld>
@@ -6974,7 +6974,7 @@
           <p:cNvPr id="9" name="">
             <a:extLst xmlns:a="http://schemas.openxmlformats.org/drawingml/2006/main">
               <a:ext uri="{FF2B5EF4-FFF2-40B4-BE49-F238E27FC236}">
-                <a16:creationId xmlns:a16="http://schemas.microsoft.com/office/drawing/2014/main" id="{01F516E3-1DB3-4193-B1B3-F3DF509DA656}"/>
+                <a16:creationId xmlns:a16="http://schemas.microsoft.com/office/drawing/2014/main" id="{C0EE01D0-0BE9-411B-B513-E452D6E90ACA}"/>
               </a:ext>
             </a:extLst>
           </p:cNvPr>
@@ -7031,7 +7031,7 @@
           <p:cNvPr id="2" name="">
             <a:extLst xmlns:a="http://schemas.openxmlformats.org/drawingml/2006/main">
               <a:ext uri="{FF2B5EF4-FFF2-40B4-BE49-F238E27FC236}">
-                <a16:creationId xmlns:a16="http://schemas.microsoft.com/office/drawing/2014/main" id="{92046CFD-87EB-4157-8F65-56F083A5FF6B}"/>
+                <a16:creationId xmlns:a16="http://schemas.microsoft.com/office/drawing/2014/main" id="{CE163C2F-59A2-4F8B-BFF1-C27B341FEACA}"/>
               </a:ext>
             </a:extLst>
           </p:cNvPr>
@@ -7088,7 +7088,7 @@
           <p:cNvPr id="3" name="">
             <a:extLst xmlns:a="http://schemas.openxmlformats.org/drawingml/2006/main">
               <a:ext uri="{FF2B5EF4-FFF2-40B4-BE49-F238E27FC236}">
-                <a16:creationId xmlns:a16="http://schemas.microsoft.com/office/drawing/2014/main" id="{4B57557C-4ED6-46D2-B642-512FD14FA1CB}"/>
+                <a16:creationId xmlns:a16="http://schemas.microsoft.com/office/drawing/2014/main" id="{B1D731EF-5D5A-4853-9B5A-BAC4336ACF05}"/>
               </a:ext>
             </a:extLst>
           </p:cNvPr>
@@ -7191,7 +7191,7 @@
           <p:cNvPr id="4" name="">
             <a:extLst xmlns:a="http://schemas.openxmlformats.org/drawingml/2006/main">
               <a:ext uri="{FF2B5EF4-FFF2-40B4-BE49-F238E27FC236}">
-                <a16:creationId xmlns:a16="http://schemas.microsoft.com/office/drawing/2014/main" id="{E7FF5C0E-A64C-44E8-B347-0469BF89F70E}"/>
+                <a16:creationId xmlns:a16="http://schemas.microsoft.com/office/drawing/2014/main" id="{984D704D-4482-47ED-8717-9C9E75E48D7A}"/>
               </a:ext>
             </a:extLst>
           </p:cNvPr>
@@ -7248,7 +7248,7 @@
           <p:cNvPr id="5" name="">
             <a:extLst xmlns:a="http://schemas.openxmlformats.org/drawingml/2006/main">
               <a:ext uri="{FF2B5EF4-FFF2-40B4-BE49-F238E27FC236}">
-                <a16:creationId xmlns:a16="http://schemas.microsoft.com/office/drawing/2014/main" id="{32102284-871A-406B-A968-27D80621D781}"/>
+                <a16:creationId xmlns:a16="http://schemas.microsoft.com/office/drawing/2014/main" id="{609FFF8C-EB34-4771-BE2F-0471DE17FEC7}"/>
               </a:ext>
             </a:extLst>
           </p:cNvPr>
@@ -7305,7 +7305,7 @@
           <p:cNvPr id="6" name="">
             <a:extLst xmlns:a="http://schemas.openxmlformats.org/drawingml/2006/main">
               <a:ext uri="{FF2B5EF4-FFF2-40B4-BE49-F238E27FC236}">
-                <a16:creationId xmlns:a16="http://schemas.microsoft.com/office/drawing/2014/main" id="{1039E944-0972-4934-92E5-183E7F27D940}"/>
+                <a16:creationId xmlns:a16="http://schemas.microsoft.com/office/drawing/2014/main" id="{A6E3E74F-48CA-43D0-8B89-FF5D2B3F2F0B}"/>
               </a:ext>
             </a:extLst>
           </p:cNvPr>
@@ -7385,7 +7385,7 @@
           <p:cNvPr id="7" name="">
             <a:extLst xmlns:a="http://schemas.openxmlformats.org/drawingml/2006/main">
               <a:ext uri="{FF2B5EF4-FFF2-40B4-BE49-F238E27FC236}">
-                <a16:creationId xmlns:a16="http://schemas.microsoft.com/office/drawing/2014/main" id="{0B4100A3-B908-4344-8CC0-7A8B828335A6}"/>
+                <a16:creationId xmlns:a16="http://schemas.microsoft.com/office/drawing/2014/main" id="{109571A4-CC71-4BCA-BCC4-09411FCEC687}"/>
               </a:ext>
             </a:extLst>
           </p:cNvPr>
@@ -7465,7 +7465,7 @@
           <p:cNvPr id="8" name="">
             <a:extLst xmlns:a="http://schemas.openxmlformats.org/drawingml/2006/main">
               <a:ext uri="{FF2B5EF4-FFF2-40B4-BE49-F238E27FC236}">
-                <a16:creationId xmlns:a16="http://schemas.microsoft.com/office/drawing/2014/main" id="{507BC988-A09B-4306-95E1-A130592857C3}"/>
+                <a16:creationId xmlns:a16="http://schemas.microsoft.com/office/drawing/2014/main" id="{BBD1D77F-9176-4B05-A2FD-22D135758391}"/>
               </a:ext>
             </a:extLst>
           </p:cNvPr>
@@ -7520,7 +7520,7 @@
     </p:spTree>
     <p:extLst>
       <p:ext uri="{BB962C8B-B14F-4D97-AF65-F5344CB8AC3E}">
-        <p14:creationId xmlns:p14="http://schemas.microsoft.com/office/powerpoint/2010/main" val="718187142"/>
+        <p14:creationId xmlns:p14="http://schemas.microsoft.com/office/powerpoint/2010/main" val="431236305"/>
       </p:ext>
     </p:extLst>
   </p:cSld>

</xml_diff>